<commit_message>
minor changes slides w1
</commit_message>
<xml_diff>
--- a/slides/PV_hoare.pptx
+++ b/slides/PV_hoare.pptx
@@ -14238,7 +14238,9 @@
         </p:nvSpPr>
         <p:spPr/>
         <p:txBody>
-          <a:bodyPr/>
+          <a:bodyPr>
+            <a:normAutofit lnSpcReduction="10000"/>
+          </a:bodyPr>
           <a:lstStyle/>
           <a:p>
             <a:r>
@@ -14363,7 +14365,7 @@
               <a:t> }   S  { </a:t>
             </a:r>
             <a:r>
-              <a:rPr lang="en-US" b="1" dirty="0" err="1">
+              <a:rPr lang="en-US" b="1" dirty="0">
                 <a:solidFill>
                   <a:srgbClr val="FF0000"/>
                 </a:solidFill>
@@ -14402,7 +14404,7 @@
               <a:t>    { </a:t>
             </a:r>
             <a:r>
-              <a:rPr lang="en-US" b="1" dirty="0" err="1">
+              <a:rPr lang="en-US" b="1" dirty="0">
                 <a:solidFill>
                   <a:srgbClr val="0070C0"/>
                 </a:solidFill>
@@ -14437,6 +14439,99 @@
             <a:r>
               <a:rPr lang="en-US" dirty="0"/>
               <a:t>}</a:t>
+            </a:r>
+          </a:p>
+          <a:p>
+            <a:pPr>
+              <a:buNone/>
+            </a:pPr>
+            <a:endParaRPr lang="en-US" dirty="0"/>
+          </a:p>
+          <a:p>
+            <a:pPr>
+              <a:buNone/>
+            </a:pPr>
+            <a:r>
+              <a:rPr lang="en-US" dirty="0"/>
+              <a:t>      It follows that to prove  {P} S {Q}, we can prove  </a:t>
+            </a:r>
+            <a:r>
+              <a:rPr lang="en-US" b="1" dirty="0">
+                <a:solidFill>
+                  <a:srgbClr val="FF0000"/>
+                </a:solidFill>
+              </a:rPr>
+              <a:t>cp</a:t>
+            </a:r>
+            <a:r>
+              <a:rPr lang="en-US" b="1" dirty="0">
+                <a:solidFill>
+                  <a:srgbClr val="FF0000"/>
+                </a:solidFill>
+                <a:sym typeface="Wingdings 3" pitchFamily="18" charset="2"/>
+              </a:rPr>
+              <a:t></a:t>
+            </a:r>
+            <a:r>
+              <a:rPr lang="en-US" dirty="0"/>
+              <a:t> S  </a:t>
+            </a:r>
+            <a:r>
+              <a:rPr lang="en-US" i="1" dirty="0"/>
+              <a:t>P </a:t>
+            </a:r>
+            <a:r>
+              <a:rPr lang="en-US" dirty="0">
+                <a:sym typeface="Symbol" pitchFamily="18" charset="2"/>
+              </a:rPr>
+              <a:t> Q instead. Or, we prove</a:t>
+            </a:r>
+            <a:r>
+              <a:rPr lang="en-US" i="1" dirty="0"/>
+              <a:t> </a:t>
+            </a:r>
+            <a:r>
+              <a:rPr lang="en-US" dirty="0"/>
+              <a:t>P </a:t>
+            </a:r>
+            <a:r>
+              <a:rPr lang="en-US" dirty="0">
+                <a:sym typeface="Symbol" pitchFamily="18" charset="2"/>
+              </a:rPr>
+              <a:t></a:t>
+            </a:r>
+            <a:r>
+              <a:rPr lang="en-US" dirty="0"/>
+              <a:t> </a:t>
+            </a:r>
+            <a:r>
+              <a:rPr lang="en-US" b="1" dirty="0">
+                <a:solidFill>
+                  <a:srgbClr val="0070C0"/>
+                </a:solidFill>
+              </a:rPr>
+              <a:t>cp</a:t>
+            </a:r>
+            <a:r>
+              <a:rPr lang="en-US" b="1" dirty="0">
+                <a:solidFill>
+                  <a:srgbClr val="0070C0"/>
+                </a:solidFill>
+                <a:sym typeface="Wingdings 3" pitchFamily="18" charset="2"/>
+              </a:rPr>
+              <a:t></a:t>
+            </a:r>
+            <a:r>
+              <a:rPr lang="en-US" dirty="0"/>
+              <a:t> S  </a:t>
+            </a:r>
+            <a:r>
+              <a:rPr lang="en-US" i="1" dirty="0"/>
+              <a:t>Q</a:t>
+            </a:r>
+            <a:r>
+              <a:rPr lang="en-US" dirty="0"/>
+              <a:t>  instead.</a:t>
             </a:r>
           </a:p>
         </p:txBody>
@@ -14538,6 +14633,160 @@
         <p:txBody>
           <a:bodyPr/>
           <a:lstStyle/>
+          <a:p>
+            <a:r>
+              <a:rPr lang="en-US" dirty="0"/>
+              <a:t>Complete if:</a:t>
+            </a:r>
+          </a:p>
+          <a:p>
+            <a:pPr marL="0" indent="0">
+              <a:buNone/>
+            </a:pPr>
+            <a:r>
+              <a:rPr lang="en-US" dirty="0"/>
+              <a:t>     { </a:t>
+            </a:r>
+            <a:r>
+              <a:rPr lang="en-US" i="1" dirty="0"/>
+              <a:t>P</a:t>
+            </a:r>
+            <a:r>
+              <a:rPr lang="en-US" dirty="0"/>
+              <a:t> }   S  { </a:t>
+            </a:r>
+            <a:r>
+              <a:rPr lang="en-US" i="1" dirty="0"/>
+              <a:t>Q </a:t>
+            </a:r>
+            <a:r>
+              <a:rPr lang="en-US" dirty="0"/>
+              <a:t>}     implies</a:t>
+            </a:r>
+            <a:r>
+              <a:rPr lang="en-US" dirty="0">
+                <a:sym typeface="Symbol" pitchFamily="18" charset="2"/>
+              </a:rPr>
+              <a:t>      </a:t>
+            </a:r>
+            <a:r>
+              <a:rPr lang="en-US" b="1" dirty="0">
+                <a:solidFill>
+                  <a:srgbClr val="FF0000"/>
+                </a:solidFill>
+              </a:rPr>
+              <a:t>cp</a:t>
+            </a:r>
+            <a:r>
+              <a:rPr lang="en-US" b="1" dirty="0">
+                <a:solidFill>
+                  <a:srgbClr val="FF0000"/>
+                </a:solidFill>
+                <a:sym typeface="Wingdings 3" pitchFamily="18" charset="2"/>
+              </a:rPr>
+              <a:t></a:t>
+            </a:r>
+            <a:r>
+              <a:rPr lang="en-US" dirty="0"/>
+              <a:t> S  </a:t>
+            </a:r>
+            <a:r>
+              <a:rPr lang="en-US" i="1" dirty="0"/>
+              <a:t>P </a:t>
+            </a:r>
+            <a:r>
+              <a:rPr lang="en-US" dirty="0"/>
+              <a:t> </a:t>
+            </a:r>
+            <a:r>
+              <a:rPr lang="en-US" dirty="0">
+                <a:sym typeface="Symbol" pitchFamily="18" charset="2"/>
+              </a:rPr>
+              <a:t>  </a:t>
+            </a:r>
+            <a:r>
+              <a:rPr lang="en-US" i="1" dirty="0">
+                <a:sym typeface="Symbol" pitchFamily="18" charset="2"/>
+              </a:rPr>
+              <a:t>Q    valid</a:t>
+            </a:r>
+            <a:r>
+              <a:rPr lang="en-US" dirty="0"/>
+              <a:t> </a:t>
+            </a:r>
+            <a:br>
+              <a:rPr lang="en-US" dirty="0"/>
+            </a:br>
+            <a:r>
+              <a:rPr lang="en-US" dirty="0"/>
+              <a:t>     { </a:t>
+            </a:r>
+            <a:r>
+              <a:rPr lang="en-US" i="1" dirty="0"/>
+              <a:t>P</a:t>
+            </a:r>
+            <a:r>
+              <a:rPr lang="en-US" dirty="0"/>
+              <a:t> }   S  { </a:t>
+            </a:r>
+            <a:r>
+              <a:rPr lang="en-US" i="1" dirty="0"/>
+              <a:t>Q </a:t>
+            </a:r>
+            <a:r>
+              <a:rPr lang="en-US" dirty="0"/>
+              <a:t>}     implies</a:t>
+            </a:r>
+            <a:r>
+              <a:rPr lang="en-US" dirty="0">
+                <a:sym typeface="Symbol" pitchFamily="18" charset="2"/>
+              </a:rPr>
+              <a:t>       </a:t>
+            </a:r>
+            <a:r>
+              <a:rPr lang="en-US" i="1" dirty="0">
+                <a:sym typeface="Symbol" pitchFamily="18" charset="2"/>
+              </a:rPr>
+              <a:t>P  </a:t>
+            </a:r>
+            <a:r>
+              <a:rPr lang="en-US" dirty="0">
+                <a:sym typeface="Symbol" pitchFamily="18" charset="2"/>
+              </a:rPr>
+              <a:t>  </a:t>
+            </a:r>
+            <a:r>
+              <a:rPr lang="en-US" b="1" dirty="0">
+                <a:solidFill>
+                  <a:srgbClr val="0070C0"/>
+                </a:solidFill>
+              </a:rPr>
+              <a:t>cp</a:t>
+            </a:r>
+            <a:r>
+              <a:rPr lang="en-US" b="1" dirty="0">
+                <a:solidFill>
+                  <a:srgbClr val="0070C0"/>
+                </a:solidFill>
+                <a:sym typeface="Wingdings 3" pitchFamily="18" charset="2"/>
+              </a:rPr>
+              <a:t></a:t>
+            </a:r>
+            <a:r>
+              <a:rPr lang="en-US" dirty="0"/>
+              <a:t> S  </a:t>
+            </a:r>
+            <a:r>
+              <a:rPr lang="en-US" i="1" dirty="0"/>
+              <a:t>Q   valid</a:t>
+            </a:r>
+          </a:p>
+          <a:p>
+            <a:pPr marL="0" indent="0">
+              <a:buNone/>
+            </a:pPr>
+            <a:endParaRPr lang="en-US" dirty="0"/>
+          </a:p>
           <a:p>
             <a:r>
               <a:rPr lang="en-US" dirty="0"/>
@@ -21010,7 +21259,15 @@
           <a:p>
             <a:r>
               <a:rPr lang="en-US" dirty="0"/>
-              <a:t>More generally a symbolic state consist of a pair (C,s) where C is a constrain and s is a mapping   </a:t>
+              <a:t>More generally a symbolic state consist of a pair (</a:t>
+            </a:r>
+            <a:r>
+              <a:rPr lang="en-US" dirty="0" err="1"/>
+              <a:t>s,C</a:t>
+            </a:r>
+            <a:r>
+              <a:rPr lang="en-US" dirty="0"/>
+              <a:t>) where C is a constrain and s is a mapping   </a:t>
             </a:r>
             <a:r>
               <a:rPr lang="en-US" b="1" dirty="0">
@@ -21039,6 +21296,78 @@
               <a:t>(</a:t>
             </a:r>
             <a:r>
+              <a:rPr lang="en-US" b="1" dirty="0">
+                <a:solidFill>
+                  <a:schemeClr val="accent1"/>
+                </a:solidFill>
+              </a:rPr>
+              <a:t>[x</a:t>
+            </a:r>
+            <a:r>
+              <a:rPr lang="en-US" b="1" baseline="-25000" dirty="0">
+                <a:solidFill>
+                  <a:schemeClr val="accent1"/>
+                </a:solidFill>
+              </a:rPr>
+              <a:t>1</a:t>
+            </a:r>
+            <a:r>
+              <a:rPr lang="en-US" b="1" dirty="0">
+                <a:solidFill>
+                  <a:schemeClr val="accent1"/>
+                </a:solidFill>
+              </a:rPr>
+              <a:t> ⟼ 𝛼</a:t>
+            </a:r>
+            <a:r>
+              <a:rPr lang="en-US" b="1" baseline="-25000" dirty="0">
+                <a:solidFill>
+                  <a:schemeClr val="accent1"/>
+                </a:solidFill>
+              </a:rPr>
+              <a:t>1</a:t>
+            </a:r>
+            <a:r>
+              <a:rPr lang="en-US" b="1" dirty="0">
+                <a:solidFill>
+                  <a:schemeClr val="accent1"/>
+                </a:solidFill>
+              </a:rPr>
+              <a:t> , x</a:t>
+            </a:r>
+            <a:r>
+              <a:rPr lang="en-US" b="1" baseline="-25000" dirty="0">
+                <a:solidFill>
+                  <a:schemeClr val="accent1"/>
+                </a:solidFill>
+              </a:rPr>
+              <a:t>2</a:t>
+            </a:r>
+            <a:r>
+              <a:rPr lang="en-US" b="1" dirty="0">
+                <a:solidFill>
+                  <a:schemeClr val="accent1"/>
+                </a:solidFill>
+              </a:rPr>
+              <a:t> ⟼ 𝛼</a:t>
+            </a:r>
+            <a:r>
+              <a:rPr lang="en-US" b="1" baseline="-25000" dirty="0">
+                <a:solidFill>
+                  <a:schemeClr val="accent1"/>
+                </a:solidFill>
+              </a:rPr>
+              <a:t>2</a:t>
+            </a:r>
+            <a:r>
+              <a:rPr lang="en-US" b="1" dirty="0">
+                <a:solidFill>
+                  <a:schemeClr val="accent1"/>
+                </a:solidFill>
+              </a:rPr>
+              <a:t> , ... ] , </a:t>
+            </a:r>
+            <a:r>
               <a:rPr lang="en-US" i="1" dirty="0">
                 <a:solidFill>
                   <a:schemeClr val="accent1"/>
@@ -21047,84 +21376,12 @@
               <a:t>true</a:t>
             </a:r>
             <a:r>
-              <a:rPr lang="en-US" dirty="0">
+              <a:rPr lang="en-US" b="1" dirty="0">
                 <a:solidFill>
                   <a:schemeClr val="accent1"/>
                 </a:solidFill>
               </a:rPr>
-              <a:t>,</a:t>
-            </a:r>
-            <a:r>
-              <a:rPr lang="en-US" b="1" dirty="0">
-                <a:solidFill>
-                  <a:schemeClr val="accent1"/>
-                </a:solidFill>
-              </a:rPr>
-              <a:t> [x</a:t>
-            </a:r>
-            <a:r>
-              <a:rPr lang="en-US" b="1" baseline="-25000" dirty="0">
-                <a:solidFill>
-                  <a:schemeClr val="accent1"/>
-                </a:solidFill>
-              </a:rPr>
-              <a:t>1</a:t>
-            </a:r>
-            <a:r>
-              <a:rPr lang="en-US" b="1" dirty="0">
-                <a:solidFill>
-                  <a:schemeClr val="accent1"/>
-                </a:solidFill>
-              </a:rPr>
-              <a:t> ⟼ 𝛼</a:t>
-            </a:r>
-            <a:r>
-              <a:rPr lang="en-US" b="1" baseline="-25000" dirty="0">
-                <a:solidFill>
-                  <a:schemeClr val="accent1"/>
-                </a:solidFill>
-              </a:rPr>
-              <a:t>1</a:t>
-            </a:r>
-            <a:r>
-              <a:rPr lang="en-US" b="1" dirty="0">
-                <a:solidFill>
-                  <a:schemeClr val="accent1"/>
-                </a:solidFill>
-              </a:rPr>
-              <a:t> , x</a:t>
-            </a:r>
-            <a:r>
-              <a:rPr lang="en-US" b="1" baseline="-25000" dirty="0">
-                <a:solidFill>
-                  <a:schemeClr val="accent1"/>
-                </a:solidFill>
-              </a:rPr>
-              <a:t>2</a:t>
-            </a:r>
-            <a:r>
-              <a:rPr lang="en-US" b="1" dirty="0">
-                <a:solidFill>
-                  <a:schemeClr val="accent1"/>
-                </a:solidFill>
-              </a:rPr>
-              <a:t> ⟼ 𝛼</a:t>
-            </a:r>
-            <a:r>
-              <a:rPr lang="en-US" b="1" baseline="-25000" dirty="0">
-                <a:solidFill>
-                  <a:schemeClr val="accent1"/>
-                </a:solidFill>
-              </a:rPr>
-              <a:t>2</a:t>
-            </a:r>
-            <a:r>
-              <a:rPr lang="en-US" b="1" dirty="0">
-                <a:solidFill>
-                  <a:schemeClr val="accent1"/>
-                </a:solidFill>
-              </a:rPr>
-              <a:t> , ... ] ) </a:t>
+              <a:t>) </a:t>
             </a:r>
             <a:r>
               <a:rPr lang="en-US" dirty="0"/>
@@ -21158,7 +21415,15 @@
           <a:p>
             <a:r>
               <a:rPr lang="en-US" dirty="0"/>
-              <a:t>Given a program path 𝜌 (sequence of instructions), and an initial symbolic state (C,s), to symbolically execute 𝜌 we simply execute the instructions in 𝜌 in the order as they appear, passing on the new symbolic state after an instruction 𝜌</a:t>
+              <a:t>Given a program path 𝜌 (sequence of instructions), and an initial symbolic state (</a:t>
+            </a:r>
+            <a:r>
+              <a:rPr lang="en-US" dirty="0" err="1"/>
+              <a:t>s,C</a:t>
+            </a:r>
+            <a:r>
+              <a:rPr lang="en-US" dirty="0"/>
+              <a:t>), to symbolically execute 𝜌 we simply execute the instructions in 𝜌 in the order as they appear, passing on the new symbolic state after an instruction 𝜌</a:t>
             </a:r>
             <a:r>
               <a:rPr lang="en-US" baseline="-25000" dirty="0"/>
@@ -21200,7 +21465,15 @@
             </a:r>
             <a:r>
               <a:rPr lang="en-US" dirty="0"/>
-              <a:t> on (C,s) gives (P ∧ C, s) as the new symbolic state.</a:t>
+              <a:t> on (</a:t>
+            </a:r>
+            <a:r>
+              <a:rPr lang="en-US" dirty="0" err="1"/>
+              <a:t>s,C</a:t>
+            </a:r>
+            <a:r>
+              <a:rPr lang="en-US" dirty="0"/>
+              <a:t>) gives (s, P ∧ C) as the new symbolic state.</a:t>
             </a:r>
           </a:p>
           <a:p>
@@ -21226,7 +21499,23 @@
             </a:r>
             <a:r>
               <a:rPr lang="en-US" dirty="0"/>
-              <a:t> on (C,s) gives the same state (C, s) as the new symbolic state, if C ∧ s ⟹ Q holds. Else the execution is aborted, reporting an error (the asserted Q is violated).</a:t>
+              <a:t> on (</a:t>
+            </a:r>
+            <a:r>
+              <a:rPr lang="en-US" dirty="0" err="1"/>
+              <a:t>s,C</a:t>
+            </a:r>
+            <a:r>
+              <a:rPr lang="en-US" dirty="0"/>
+              <a:t>) gives the same state (</a:t>
+            </a:r>
+            <a:r>
+              <a:rPr lang="en-US" dirty="0" err="1"/>
+              <a:t>s,C</a:t>
+            </a:r>
+            <a:r>
+              <a:rPr lang="en-US" dirty="0"/>
+              <a:t>) as the new symbolic state, if C ∧ s ⟹ Q holds. Else the execution is aborted, reporting an error (the asserted Q is violated).</a:t>
             </a:r>
           </a:p>
           <a:p>
@@ -21244,15 +21533,31 @@
             </a:r>
             <a:r>
               <a:rPr lang="en-US" dirty="0"/>
-              <a:t>on (C,s) gives (C,  </a:t>
-            </a:r>
-            <a:r>
-              <a:rPr lang="en-US" b="1" dirty="0"/>
+              <a:t>on (</a:t>
+            </a:r>
+            <a:r>
+              <a:rPr lang="en-US" dirty="0" err="1"/>
+              <a:t>s,C</a:t>
+            </a:r>
+            <a:r>
+              <a:rPr lang="en-US" dirty="0"/>
+              <a:t>) </a:t>
+            </a:r>
+            <a:r>
+              <a:rPr lang="en-US"/>
+              <a:t>gives (</a:t>
+            </a:r>
+            <a:r>
+              <a:rPr lang="en-US" b="1"/>
               <a:t>update</a:t>
             </a:r>
             <a:r>
-              <a:rPr lang="en-US" dirty="0"/>
-              <a:t> y e’ s) as the new symbolic state, where e’ is the symbolic value of the expression e on the state s, which can be obtained by replacing every program variable z that occurs in e with s(z) (the symbolic value of z in the state s).</a:t>
+              <a:rPr lang="en-US"/>
+              <a:t> </a:t>
+            </a:r>
+            <a:r>
+              <a:rPr lang="en-US" dirty="0"/>
+              <a:t>y e’ s, C) as the new symbolic state, where e’ is the symbolic value of the expression e on the state s, which can be obtained by replacing every program variable z that occurs in e with s(z) (the symbolic value of z in the state s).</a:t>
             </a:r>
           </a:p>
           <a:p>

</xml_diff>

<commit_message>
updates on the slides of Hoare logic and slides of ltl
</commit_message>
<xml_diff>
--- a/slides/PV_hoare.pptx
+++ b/slides/PV_hoare.pptx
@@ -4224,6 +4224,185 @@
           <a:p>
             <a:r>
               <a:rPr lang="en-US" dirty="0"/>
+              <a:t>Proof  that f is also monotonic:</a:t>
+            </a:r>
+          </a:p>
+          <a:p>
+            <a:endParaRPr lang="en-US" dirty="0"/>
+          </a:p>
+          <a:p>
+            <a:r>
+              <a:rPr lang="en-US" dirty="0"/>
+              <a:t>Suppose X &lt;= Y ; to prove that f(X) &lt;= f(Y)</a:t>
+            </a:r>
+            <a:br>
+              <a:rPr lang="en-US" dirty="0"/>
+            </a:br>
+            <a:endParaRPr lang="en-US" dirty="0"/>
+          </a:p>
+          <a:p>
+            <a:pPr marL="0" marR="0" lvl="0" indent="0" algn="l" defTabSz="914400" rtl="0" eaLnBrk="0" fontAlgn="base" latinLnBrk="0" hangingPunct="0">
+              <a:lnSpc>
+                <a:spcPct val="100000"/>
+              </a:lnSpc>
+              <a:spcBef>
+                <a:spcPct val="30000"/>
+              </a:spcBef>
+              <a:spcAft>
+                <a:spcPct val="0"/>
+              </a:spcAft>
+              <a:buClrTx/>
+              <a:buSzTx/>
+              <a:buFontTx/>
+              <a:buNone/>
+              <a:tabLst/>
+              <a:defRPr/>
+            </a:pPr>
+            <a:r>
+              <a:rPr lang="en-US" dirty="0"/>
+              <a:t>     (1) since X &lt;= Y, then  X = X  </a:t>
+            </a:r>
+            <a:r>
+              <a:rPr lang="en-US" dirty="0">
+                <a:sym typeface="Symbol"/>
+              </a:rPr>
+              <a:t>  Y.</a:t>
+            </a:r>
+            <a:br>
+              <a:rPr lang="en-US" dirty="0">
+                <a:sym typeface="Symbol"/>
+              </a:rPr>
+            </a:br>
+            <a:r>
+              <a:rPr lang="en-US" dirty="0">
+                <a:sym typeface="Symbol"/>
+              </a:rPr>
+              <a:t>     (2) f(X)</a:t>
+            </a:r>
+            <a:br>
+              <a:rPr lang="en-US" dirty="0">
+                <a:sym typeface="Symbol"/>
+              </a:rPr>
+            </a:br>
+            <a:r>
+              <a:rPr lang="en-US" dirty="0">
+                <a:sym typeface="Symbol"/>
+              </a:rPr>
+              <a:t>         = // (1) above</a:t>
+            </a:r>
+            <a:br>
+              <a:rPr lang="en-US" dirty="0">
+                <a:sym typeface="Symbol"/>
+              </a:rPr>
+            </a:br>
+            <a:r>
+              <a:rPr lang="en-US" dirty="0">
+                <a:sym typeface="Symbol"/>
+              </a:rPr>
+              <a:t>         f (X  Y) </a:t>
+            </a:r>
+            <a:br>
+              <a:rPr lang="en-US" dirty="0">
+                <a:sym typeface="Symbol"/>
+              </a:rPr>
+            </a:br>
+            <a:r>
+              <a:rPr lang="en-US" dirty="0">
+                <a:sym typeface="Symbol"/>
+              </a:rPr>
+              <a:t>         =</a:t>
+            </a:r>
+            <a:r>
+              <a:rPr lang="en-US" baseline="0" dirty="0">
+                <a:sym typeface="Symbol"/>
+              </a:rPr>
+              <a:t> // </a:t>
+            </a:r>
+            <a:r>
+              <a:rPr lang="en-US" dirty="0">
+                <a:sym typeface="Symbol"/>
+              </a:rPr>
+              <a:t>-continuous</a:t>
+            </a:r>
+          </a:p>
+          <a:p>
+            <a:pPr marL="0" marR="0" lvl="0" indent="0" algn="l" defTabSz="914400" rtl="0" eaLnBrk="0" fontAlgn="base" latinLnBrk="0" hangingPunct="0">
+              <a:lnSpc>
+                <a:spcPct val="100000"/>
+              </a:lnSpc>
+              <a:spcBef>
+                <a:spcPct val="30000"/>
+              </a:spcBef>
+              <a:spcAft>
+                <a:spcPct val="0"/>
+              </a:spcAft>
+              <a:buClrTx/>
+              <a:buSzTx/>
+              <a:buFontTx/>
+              <a:buNone/>
+              <a:tabLst/>
+              <a:defRPr/>
+            </a:pPr>
+            <a:r>
+              <a:rPr lang="en-US" dirty="0"/>
+              <a:t>          f(X) </a:t>
+            </a:r>
+            <a:r>
+              <a:rPr lang="en-US" baseline="0" dirty="0">
+                <a:sym typeface="Symbol"/>
+              </a:rPr>
+              <a:t> </a:t>
+            </a:r>
+            <a:r>
+              <a:rPr lang="en-US" dirty="0">
+                <a:sym typeface="Symbol"/>
+              </a:rPr>
+              <a:t>  f(Y)</a:t>
+            </a:r>
+          </a:p>
+          <a:p>
+            <a:pPr marL="0" marR="0" lvl="0" indent="0" algn="l" defTabSz="914400" rtl="0" eaLnBrk="0" fontAlgn="base" latinLnBrk="0" hangingPunct="0">
+              <a:lnSpc>
+                <a:spcPct val="100000"/>
+              </a:lnSpc>
+              <a:spcBef>
+                <a:spcPct val="30000"/>
+              </a:spcBef>
+              <a:spcAft>
+                <a:spcPct val="0"/>
+              </a:spcAft>
+              <a:buClrTx/>
+              <a:buSzTx/>
+              <a:buFontTx/>
+              <a:buNone/>
+              <a:tabLst/>
+              <a:defRPr/>
+            </a:pPr>
+            <a:r>
+              <a:rPr lang="en-US" dirty="0">
+                <a:sym typeface="Symbol"/>
+              </a:rPr>
+              <a:t>         &lt;= // prop of intersection</a:t>
+            </a:r>
+            <a:br>
+              <a:rPr lang="en-US" dirty="0">
+                <a:sym typeface="Symbol"/>
+              </a:rPr>
+            </a:br>
+            <a:r>
+              <a:rPr lang="en-US" dirty="0">
+                <a:sym typeface="Symbol"/>
+              </a:rPr>
+              <a:t>          f(Y)</a:t>
+            </a:r>
+            <a:endParaRPr lang="en-US" dirty="0"/>
+          </a:p>
+          <a:p>
+            <a:endParaRPr lang="en-US" dirty="0"/>
+          </a:p>
+          <a:p>
+            <a:r>
+              <a:rPr lang="en-US" dirty="0"/>
               <a:t>Proof</a:t>
             </a:r>
             <a:r>
@@ -4232,7 +4411,7 @@
             </a:r>
             <a:r>
               <a:rPr lang="en-US" dirty="0"/>
-              <a:t>∑)</a:t>
+              <a:t>∑) about the fix point:</a:t>
             </a:r>
           </a:p>
           <a:p>
@@ -5257,12 +5436,10 @@
         </p:nvSpPr>
         <p:spPr/>
         <p:txBody>
-          <a:bodyPr>
-            <a:normAutofit/>
-          </a:bodyPr>
+          <a:bodyPr/>
           <a:lstStyle/>
           <a:p>
-            <a:endParaRPr lang="en-US" baseline="0" dirty="0"/>
+            <a:endParaRPr lang="en-NL" dirty="0"/>
           </a:p>
         </p:txBody>
       </p:sp>
@@ -5273,7 +5450,7 @@
             <a:spLocks noGrp="1"/>
           </p:cNvSpPr>
           <p:nvPr>
-            <p:ph type="sldNum" sz="quarter" idx="10"/>
+            <p:ph type="sldNum" sz="quarter" idx="5"/>
           </p:nvPr>
         </p:nvSpPr>
         <p:spPr/>
@@ -5289,7 +5466,7 @@
               <a:pPr>
                 <a:defRPr/>
               </a:pPr>
-              <a:t>47</a:t>
+              <a:t>46</a:t>
             </a:fld>
             <a:endParaRPr lang="en-US"/>
           </a:p>
@@ -5298,7 +5475,7 @@
     </p:spTree>
     <p:extLst>
       <p:ext uri="{BB962C8B-B14F-4D97-AF65-F5344CB8AC3E}">
-        <p14:creationId xmlns:p14="http://schemas.microsoft.com/office/powerpoint/2010/main" val="2143032214"/>
+        <p14:creationId xmlns:p14="http://schemas.microsoft.com/office/powerpoint/2010/main" val="2099083580"/>
       </p:ext>
     </p:extLst>
   </p:cSld>
@@ -5381,7 +5558,7 @@
               <a:pPr>
                 <a:defRPr/>
               </a:pPr>
-              <a:t>48</a:t>
+              <a:t>47</a:t>
             </a:fld>
             <a:endParaRPr lang="en-US"/>
           </a:p>
@@ -5390,7 +5567,7 @@
     </p:spTree>
     <p:extLst>
       <p:ext uri="{BB962C8B-B14F-4D97-AF65-F5344CB8AC3E}">
-        <p14:creationId xmlns:p14="http://schemas.microsoft.com/office/powerpoint/2010/main" val="1373802605"/>
+        <p14:creationId xmlns:p14="http://schemas.microsoft.com/office/powerpoint/2010/main" val="2143032214"/>
       </p:ext>
     </p:extLst>
   </p:cSld>
@@ -5473,7 +5650,7 @@
               <a:pPr>
                 <a:defRPr/>
               </a:pPr>
-              <a:t>49</a:t>
+              <a:t>48</a:t>
             </a:fld>
             <a:endParaRPr lang="en-US"/>
           </a:p>
@@ -5482,7 +5659,7 @@
     </p:spTree>
     <p:extLst>
       <p:ext uri="{BB962C8B-B14F-4D97-AF65-F5344CB8AC3E}">
-        <p14:creationId xmlns:p14="http://schemas.microsoft.com/office/powerpoint/2010/main" val="4051856972"/>
+        <p14:creationId xmlns:p14="http://schemas.microsoft.com/office/powerpoint/2010/main" val="1373802605"/>
       </p:ext>
     </p:extLst>
   </p:cSld>
@@ -5649,154 +5826,12 @@
         </p:nvSpPr>
         <p:spPr/>
         <p:txBody>
-          <a:bodyPr/>
+          <a:bodyPr>
+            <a:normAutofit/>
+          </a:bodyPr>
           <a:lstStyle/>
           <a:p>
-            <a:r>
-              <a:rPr lang="en-US" dirty="0"/>
-              <a:t>Recall, </a:t>
-            </a:r>
-            <a:r>
-              <a:rPr lang="en-US" dirty="0" err="1"/>
-              <a:t>wlp</a:t>
-            </a:r>
-            <a:r>
-              <a:rPr lang="en-US" dirty="0"/>
-              <a:t> is sound if:  P </a:t>
-            </a:r>
-            <a:r>
-              <a:rPr lang="en-US" dirty="0">
-                <a:sym typeface="Wingdings"/>
-              </a:rPr>
-              <a:t>==&gt;</a:t>
-            </a:r>
-            <a:r>
-              <a:rPr lang="en-US" baseline="0" dirty="0">
-                <a:sym typeface="Wingdings"/>
-              </a:rPr>
-              <a:t> </a:t>
-            </a:r>
-            <a:r>
-              <a:rPr lang="en-US" baseline="0" dirty="0" err="1">
-                <a:sym typeface="Wingdings"/>
-              </a:rPr>
-              <a:t>wlp</a:t>
-            </a:r>
-            <a:r>
-              <a:rPr lang="en-US" baseline="0" dirty="0">
-                <a:sym typeface="Wingdings"/>
-              </a:rPr>
-              <a:t> S Q  implies {P} S {Q} is also valid. </a:t>
-            </a:r>
-            <a:br>
-              <a:rPr lang="en-US" baseline="0" dirty="0">
-                <a:sym typeface="Wingdings"/>
-              </a:rPr>
-            </a:br>
-            <a:br>
-              <a:rPr lang="en-US" baseline="0" dirty="0">
-                <a:sym typeface="Wingdings"/>
-              </a:rPr>
-            </a:br>
-            <a:r>
-              <a:rPr lang="en-US" baseline="0" dirty="0">
-                <a:sym typeface="Wingdings"/>
-              </a:rPr>
-              <a:t>Whereas a complete </a:t>
-            </a:r>
-            <a:r>
-              <a:rPr lang="en-US" baseline="0" dirty="0" err="1">
-                <a:sym typeface="Wingdings"/>
-              </a:rPr>
-              <a:t>wlp</a:t>
-            </a:r>
-            <a:r>
-              <a:rPr lang="en-US" baseline="0" dirty="0">
-                <a:sym typeface="Wingdings"/>
-              </a:rPr>
-              <a:t> means:  if {P} S {Q} then P ==&gt; </a:t>
-            </a:r>
-            <a:r>
-              <a:rPr lang="en-US" baseline="0" dirty="0" err="1">
-                <a:sym typeface="Wingdings"/>
-              </a:rPr>
-              <a:t>wlp</a:t>
-            </a:r>
-            <a:r>
-              <a:rPr lang="en-US" baseline="0" dirty="0">
-                <a:sym typeface="Wingdings"/>
-              </a:rPr>
-              <a:t> S Q. </a:t>
-            </a:r>
-          </a:p>
-          <a:p>
-            <a:r>
-              <a:rPr lang="en-US" baseline="0" dirty="0">
-                <a:sym typeface="Wingdings"/>
-              </a:rPr>
-              <a:t>So, in this case knowing that P ==&gt; </a:t>
-            </a:r>
-            <a:r>
-              <a:rPr lang="en-US" baseline="0" dirty="0" err="1">
-                <a:sym typeface="Wingdings"/>
-              </a:rPr>
-              <a:t>wlp</a:t>
-            </a:r>
-            <a:r>
-              <a:rPr lang="en-US" baseline="0" dirty="0">
-                <a:sym typeface="Wingdings"/>
-              </a:rPr>
-              <a:t> S Q does not tell us anything about the validity</a:t>
-            </a:r>
-          </a:p>
-          <a:p>
-            <a:r>
-              <a:rPr lang="en-US" baseline="0" dirty="0">
-                <a:sym typeface="Wingdings"/>
-              </a:rPr>
-              <a:t>of {P} S {Q}. HOWEVER, by contraposition, if P ==&gt; </a:t>
-            </a:r>
-            <a:r>
-              <a:rPr lang="en-US" baseline="0" dirty="0" err="1">
-                <a:sym typeface="Wingdings"/>
-              </a:rPr>
-              <a:t>wlp</a:t>
-            </a:r>
-            <a:r>
-              <a:rPr lang="en-US" baseline="0" dirty="0">
-                <a:sym typeface="Wingdings"/>
-              </a:rPr>
-              <a:t> S Q turns out to be</a:t>
-            </a:r>
-          </a:p>
-          <a:p>
-            <a:r>
-              <a:rPr lang="en-US" baseline="0" dirty="0">
-                <a:sym typeface="Wingdings"/>
-              </a:rPr>
-              <a:t>invalid, then {P} S {Q} is not valid either. In other words, a bug found using an</a:t>
-            </a:r>
-          </a:p>
-          <a:p>
-            <a:r>
-              <a:rPr lang="en-US" baseline="0" dirty="0">
-                <a:sym typeface="Wingdings"/>
-              </a:rPr>
-              <a:t>incomplete </a:t>
-            </a:r>
-            <a:r>
-              <a:rPr lang="en-US" baseline="0" dirty="0" err="1">
-                <a:sym typeface="Wingdings"/>
-              </a:rPr>
-              <a:t>wlp</a:t>
-            </a:r>
-            <a:r>
-              <a:rPr lang="en-US" baseline="0" dirty="0">
-                <a:sym typeface="Wingdings"/>
-              </a:rPr>
-              <a:t> would be a real bug.</a:t>
-            </a:r>
-            <a:endParaRPr lang="en-US" dirty="0"/>
+            <a:endParaRPr lang="en-US" baseline="0" dirty="0"/>
           </a:p>
         </p:txBody>
       </p:sp>
@@ -5823,7 +5858,7 @@
               <a:pPr>
                 <a:defRPr/>
               </a:pPr>
-              <a:t>50</a:t>
+              <a:t>49</a:t>
             </a:fld>
             <a:endParaRPr lang="en-US"/>
           </a:p>
@@ -5832,7 +5867,7 @@
     </p:spTree>
     <p:extLst>
       <p:ext uri="{BB962C8B-B14F-4D97-AF65-F5344CB8AC3E}">
-        <p14:creationId xmlns:p14="http://schemas.microsoft.com/office/powerpoint/2010/main" val="1719672993"/>
+        <p14:creationId xmlns:p14="http://schemas.microsoft.com/office/powerpoint/2010/main" val="4051856972"/>
       </p:ext>
     </p:extLst>
   </p:cSld>
@@ -5888,66 +5923,149 @@
           <a:p>
             <a:r>
               <a:rPr lang="en-US" dirty="0"/>
-              <a:t>If y&gt;0 </a:t>
+              <a:t>Recall, </a:t>
+            </a:r>
+            <a:r>
+              <a:rPr lang="en-US" dirty="0" err="1"/>
+              <a:t>wlp</a:t>
+            </a:r>
+            <a:r>
+              <a:rPr lang="en-US" dirty="0"/>
+              <a:t> is sound if:  P </a:t>
+            </a:r>
+            <a:r>
+              <a:rPr lang="en-US" dirty="0">
+                <a:sym typeface="Wingdings"/>
+              </a:rPr>
+              <a:t>==&gt;</a:t>
+            </a:r>
+            <a:r>
+              <a:rPr lang="en-US" baseline="0" dirty="0">
+                <a:sym typeface="Wingdings"/>
+              </a:rPr>
+              <a:t> </a:t>
+            </a:r>
+            <a:r>
+              <a:rPr lang="en-US" baseline="0" dirty="0" err="1">
+                <a:sym typeface="Wingdings"/>
+              </a:rPr>
+              <a:t>wlp</a:t>
+            </a:r>
+            <a:r>
+              <a:rPr lang="en-US" baseline="0" dirty="0">
+                <a:sym typeface="Wingdings"/>
+              </a:rPr>
+              <a:t> S Q  implies {P} S {Q} is also valid. </a:t>
             </a:r>
             <a:br>
-              <a:rPr lang="en-US" dirty="0"/>
+              <a:rPr lang="en-US" baseline="0" dirty="0">
+                <a:sym typeface="Wingdings"/>
+              </a:rPr>
             </a:br>
-            <a:r>
-              <a:rPr lang="en-US" dirty="0"/>
-              <a:t>    then y := y-1 ; if y&gt;0 </a:t>
-            </a:r>
             <a:br>
-              <a:rPr lang="en-US" dirty="0"/>
+              <a:rPr lang="en-US" baseline="0" dirty="0">
+                <a:sym typeface="Wingdings"/>
+              </a:rPr>
             </a:br>
             <a:r>
-              <a:rPr lang="en-US" dirty="0"/>
-              <a:t>                             then y := y-1 ; assume y&lt;=0</a:t>
-            </a:r>
-            <a:br>
-              <a:rPr lang="en-US" dirty="0"/>
-            </a:br>
-            <a:r>
-              <a:rPr lang="en-US" dirty="0"/>
-              <a:t>                             else skip</a:t>
-            </a:r>
-            <a:br>
-              <a:rPr lang="en-US" dirty="0"/>
-            </a:br>
-            <a:r>
-              <a:rPr lang="en-US" dirty="0"/>
-              <a:t>    else skip</a:t>
-            </a:r>
-            <a:br>
-              <a:rPr lang="en-US" dirty="0"/>
-            </a:br>
-            <a:r>
-              <a:rPr lang="en-US" dirty="0"/>
-              <a:t>{ y = 0 }</a:t>
-            </a:r>
-            <a:br>
-              <a:rPr lang="en-US" dirty="0"/>
-            </a:br>
+              <a:rPr lang="en-US" baseline="0" dirty="0">
+                <a:sym typeface="Wingdings"/>
+              </a:rPr>
+              <a:t>Whereas a complete </a:t>
+            </a:r>
+            <a:r>
+              <a:rPr lang="en-US" baseline="0" dirty="0" err="1">
+                <a:sym typeface="Wingdings"/>
+              </a:rPr>
+              <a:t>wlp</a:t>
+            </a:r>
+            <a:r>
+              <a:rPr lang="en-US" baseline="0" dirty="0">
+                <a:sym typeface="Wingdings"/>
+              </a:rPr>
+              <a:t> means:  if {P} S {Q} then P ==&gt; </a:t>
+            </a:r>
+            <a:r>
+              <a:rPr lang="en-US" baseline="0" dirty="0" err="1">
+                <a:sym typeface="Wingdings"/>
+              </a:rPr>
+              <a:t>wlp</a:t>
+            </a:r>
+            <a:r>
+              <a:rPr lang="en-US" baseline="0" dirty="0">
+                <a:sym typeface="Wingdings"/>
+              </a:rPr>
+              <a:t> S Q. </a:t>
+            </a:r>
+          </a:p>
+          <a:p>
+            <a:r>
+              <a:rPr lang="en-US" baseline="0" dirty="0">
+                <a:sym typeface="Wingdings"/>
+              </a:rPr>
+              <a:t>So, in this case knowing that P ==&gt; </a:t>
+            </a:r>
+            <a:r>
+              <a:rPr lang="en-US" baseline="0" dirty="0" err="1">
+                <a:sym typeface="Wingdings"/>
+              </a:rPr>
+              <a:t>wlp</a:t>
+            </a:r>
+            <a:r>
+              <a:rPr lang="en-US" baseline="0" dirty="0">
+                <a:sym typeface="Wingdings"/>
+              </a:rPr>
+              <a:t> S Q does not tell us anything about the validity</a:t>
+            </a:r>
+          </a:p>
+          <a:p>
+            <a:r>
+              <a:rPr lang="en-US" baseline="0" dirty="0">
+                <a:sym typeface="Wingdings"/>
+              </a:rPr>
+              <a:t>of {P} S {Q}. HOWEVER, by contraposition, if P ==&gt; </a:t>
+            </a:r>
+            <a:r>
+              <a:rPr lang="en-US" baseline="0" dirty="0" err="1">
+                <a:sym typeface="Wingdings"/>
+              </a:rPr>
+              <a:t>wlp</a:t>
+            </a:r>
+            <a:r>
+              <a:rPr lang="en-US" baseline="0" dirty="0">
+                <a:sym typeface="Wingdings"/>
+              </a:rPr>
+              <a:t> S Q turns out to be</a:t>
+            </a:r>
+          </a:p>
+          <a:p>
+            <a:r>
+              <a:rPr lang="en-US" baseline="0" dirty="0">
+                <a:sym typeface="Wingdings"/>
+              </a:rPr>
+              <a:t>invalid, then {P} S {Q} is not valid either. In other words, a bug found using an</a:t>
+            </a:r>
+          </a:p>
+          <a:p>
+            <a:r>
+              <a:rPr lang="en-US" baseline="0" dirty="0">
+                <a:sym typeface="Wingdings"/>
+              </a:rPr>
+              <a:t>incomplete </a:t>
+            </a:r>
+            <a:r>
+              <a:rPr lang="en-US" baseline="0" dirty="0" err="1">
+                <a:sym typeface="Wingdings"/>
+              </a:rPr>
+              <a:t>wlp</a:t>
+            </a:r>
+            <a:r>
+              <a:rPr lang="en-US" baseline="0" dirty="0">
+                <a:sym typeface="Wingdings"/>
+              </a:rPr>
+              <a:t> would be a real bug.</a:t>
+            </a:r>
             <a:endParaRPr lang="en-US" dirty="0"/>
-          </a:p>
-          <a:p>
-            <a:r>
-              <a:rPr lang="en-US" dirty="0"/>
-              <a:t>WLP = (y=0) \/ (y=1) \/ (y&gt;=2</a:t>
-            </a:r>
-            <a:r>
-              <a:rPr lang="en-US" dirty="0">
-                <a:sym typeface="Wingdings" pitchFamily="2" charset="2"/>
-              </a:rPr>
-              <a:t>)</a:t>
-            </a:r>
-            <a:br>
-              <a:rPr lang="en-US" dirty="0"/>
-            </a:br>
-            <a:r>
-              <a:rPr lang="en-US" dirty="0"/>
-              <a:t> </a:t>
-            </a:r>
           </a:p>
         </p:txBody>
       </p:sp>
@@ -5958,7 +6076,7 @@
             <a:spLocks noGrp="1"/>
           </p:cNvSpPr>
           <p:nvPr>
-            <p:ph type="sldNum" sz="quarter" idx="5"/>
+            <p:ph type="sldNum" sz="quarter" idx="10"/>
           </p:nvPr>
         </p:nvSpPr>
         <p:spPr/>
@@ -5974,7 +6092,7 @@
               <a:pPr>
                 <a:defRPr/>
               </a:pPr>
-              <a:t>52</a:t>
+              <a:t>50</a:t>
             </a:fld>
             <a:endParaRPr lang="en-US"/>
           </a:p>
@@ -5983,7 +6101,7 @@
     </p:spTree>
     <p:extLst>
       <p:ext uri="{BB962C8B-B14F-4D97-AF65-F5344CB8AC3E}">
-        <p14:creationId xmlns:p14="http://schemas.microsoft.com/office/powerpoint/2010/main" val="1768339986"/>
+        <p14:creationId xmlns:p14="http://schemas.microsoft.com/office/powerpoint/2010/main" val="1719672993"/>
       </p:ext>
     </p:extLst>
   </p:cSld>
@@ -6034,66 +6152,71 @@
         </p:nvSpPr>
         <p:spPr/>
         <p:txBody>
-          <a:bodyPr>
-            <a:normAutofit/>
-          </a:bodyPr>
+          <a:bodyPr/>
           <a:lstStyle/>
           <a:p>
             <a:r>
               <a:rPr lang="en-US" dirty="0"/>
-              <a:t>The first example should result in (</a:t>
-            </a:r>
-            <a:r>
-              <a:rPr lang="en-US" dirty="0" err="1"/>
-              <a:t>Forall</a:t>
-            </a:r>
-            <a:r>
-              <a:rPr lang="en-US" dirty="0"/>
-              <a:t> x’ :: x = y+1) which is equivalent to</a:t>
-            </a:r>
-            <a:r>
-              <a:rPr lang="en-US" baseline="0" dirty="0"/>
-              <a:t> just x=y+1.</a:t>
-            </a:r>
+              <a:t>If y&gt;0 </a:t>
+            </a:r>
+            <a:br>
+              <a:rPr lang="en-US" dirty="0"/>
+            </a:br>
+            <a:r>
+              <a:rPr lang="en-US" dirty="0"/>
+              <a:t>    then y := y-1 ; if y&gt;0 </a:t>
+            </a:r>
+            <a:br>
+              <a:rPr lang="en-US" dirty="0"/>
+            </a:br>
+            <a:r>
+              <a:rPr lang="en-US" dirty="0"/>
+              <a:t>                             then y := y-1 ; assume y&lt;=0</a:t>
+            </a:r>
+            <a:br>
+              <a:rPr lang="en-US" dirty="0"/>
+            </a:br>
+            <a:r>
+              <a:rPr lang="en-US" dirty="0"/>
+              <a:t>                             else skip</a:t>
+            </a:r>
+            <a:br>
+              <a:rPr lang="en-US" dirty="0"/>
+            </a:br>
+            <a:r>
+              <a:rPr lang="en-US" dirty="0"/>
+              <a:t>    else skip</a:t>
+            </a:r>
+            <a:br>
+              <a:rPr lang="en-US" dirty="0"/>
+            </a:br>
+            <a:r>
+              <a:rPr lang="en-US" dirty="0"/>
+              <a:t>{ y = 0 }</a:t>
+            </a:r>
+            <a:br>
+              <a:rPr lang="en-US" dirty="0"/>
+            </a:br>
             <a:endParaRPr lang="en-US" dirty="0"/>
           </a:p>
           <a:p>
-            <a:endParaRPr lang="en-US" dirty="0"/>
-          </a:p>
-          <a:p>
-            <a:r>
-              <a:rPr lang="en-US" dirty="0"/>
-              <a:t>The second example should</a:t>
-            </a:r>
-            <a:r>
-              <a:rPr lang="en-US" baseline="0" dirty="0"/>
-              <a:t> result in (</a:t>
-            </a:r>
-            <a:r>
-              <a:rPr lang="en-US" baseline="0" dirty="0" err="1"/>
-              <a:t>Forall</a:t>
-            </a:r>
-            <a:r>
-              <a:rPr lang="en-US" baseline="0" dirty="0"/>
-              <a:t> x’ : x’&gt;0 : x = </a:t>
-            </a:r>
-            <a:r>
-              <a:rPr lang="en-US" baseline="0" dirty="0" err="1"/>
-              <a:t>y+x</a:t>
-            </a:r>
-            <a:r>
-              <a:rPr lang="en-US" baseline="0" dirty="0"/>
-              <a:t>’)  which is not a </a:t>
-            </a:r>
-            <a:r>
-              <a:rPr lang="en-US" baseline="0" dirty="0" err="1"/>
-              <a:t>satisfiable</a:t>
-            </a:r>
-            <a:r>
-              <a:rPr lang="en-US" baseline="0" dirty="0"/>
-              <a:t> formula.</a:t>
-            </a:r>
-            <a:endParaRPr lang="en-US" dirty="0"/>
+            <a:r>
+              <a:rPr lang="en-US" dirty="0"/>
+              <a:t>WLP = (y=0) \/ (y=1) \/ (y&gt;=2</a:t>
+            </a:r>
+            <a:r>
+              <a:rPr lang="en-US" dirty="0">
+                <a:sym typeface="Wingdings" pitchFamily="2" charset="2"/>
+              </a:rPr>
+              <a:t>)</a:t>
+            </a:r>
+            <a:br>
+              <a:rPr lang="en-US" dirty="0"/>
+            </a:br>
+            <a:r>
+              <a:rPr lang="en-US" dirty="0"/>
+              <a:t> </a:t>
+            </a:r>
           </a:p>
         </p:txBody>
       </p:sp>
@@ -6104,7 +6227,7 @@
             <a:spLocks noGrp="1"/>
           </p:cNvSpPr>
           <p:nvPr>
-            <p:ph type="sldNum" sz="quarter" idx="10"/>
+            <p:ph type="sldNum" sz="quarter" idx="5"/>
           </p:nvPr>
         </p:nvSpPr>
         <p:spPr/>
@@ -6120,7 +6243,7 @@
               <a:pPr>
                 <a:defRPr/>
               </a:pPr>
-              <a:t>54</a:t>
+              <a:t>52</a:t>
             </a:fld>
             <a:endParaRPr lang="en-US"/>
           </a:p>
@@ -6129,7 +6252,7 @@
     </p:spTree>
     <p:extLst>
       <p:ext uri="{BB962C8B-B14F-4D97-AF65-F5344CB8AC3E}">
-        <p14:creationId xmlns:p14="http://schemas.microsoft.com/office/powerpoint/2010/main" val="346693214"/>
+        <p14:creationId xmlns:p14="http://schemas.microsoft.com/office/powerpoint/2010/main" val="1768339986"/>
       </p:ext>
     </p:extLst>
   </p:cSld>
@@ -6180,115 +6303,65 @@
         </p:nvSpPr>
         <p:spPr/>
         <p:txBody>
-          <a:bodyPr/>
+          <a:bodyPr>
+            <a:normAutofit/>
+          </a:bodyPr>
           <a:lstStyle/>
           <a:p>
             <a:r>
               <a:rPr lang="en-US" dirty="0"/>
-              <a:t>(x=y)</a:t>
+              <a:t>The first example should result in (</a:t>
+            </a:r>
+            <a:r>
+              <a:rPr lang="en-US" dirty="0" err="1"/>
+              <a:t>Forall</a:t>
+            </a:r>
+            <a:r>
+              <a:rPr lang="en-US" dirty="0"/>
+              <a:t> x’ :: x = y+1) which is equivalent to</a:t>
             </a:r>
             <a:r>
               <a:rPr lang="en-US" baseline="0" dirty="0"/>
-              <a:t> [</a:t>
+              <a:t> just x=y+1.</a:t>
+            </a:r>
+            <a:endParaRPr lang="en-US" dirty="0"/>
+          </a:p>
+          <a:p>
+            <a:endParaRPr lang="en-US" dirty="0"/>
+          </a:p>
+          <a:p>
+            <a:r>
+              <a:rPr lang="en-US" dirty="0"/>
+              <a:t>The second example should</a:t>
+            </a:r>
+            <a:r>
+              <a:rPr lang="en-US" baseline="0" dirty="0"/>
+              <a:t> result in (</a:t>
             </a:r>
             <a:r>
               <a:rPr lang="en-US" baseline="0" dirty="0" err="1"/>
-              <a:t>y,x+y</a:t>
+              <a:t>Forall</a:t>
             </a:r>
             <a:r>
               <a:rPr lang="en-US" baseline="0" dirty="0"/>
-              <a:t> / </a:t>
+              <a:t> x’ : x’&gt;0 : x = </a:t>
             </a:r>
             <a:r>
               <a:rPr lang="en-US" baseline="0" dirty="0" err="1"/>
-              <a:t>x,y</a:t>
+              <a:t>y+x</a:t>
             </a:r>
             <a:r>
               <a:rPr lang="en-US" baseline="0" dirty="0"/>
-              <a:t>] </a:t>
-            </a:r>
-            <a:r>
-              <a:rPr lang="en-US" baseline="0" dirty="0">
-                <a:sym typeface="Wingdings"/>
-              </a:rPr>
-              <a:t> y=</a:t>
-            </a:r>
-            <a:r>
-              <a:rPr lang="en-US" baseline="0" dirty="0" err="1">
-                <a:sym typeface="Wingdings"/>
-              </a:rPr>
-              <a:t>x+y</a:t>
-            </a:r>
-            <a:endParaRPr lang="en-US" baseline="0" dirty="0">
-              <a:sym typeface="Wingdings"/>
-            </a:endParaRPr>
-          </a:p>
-          <a:p>
-            <a:endParaRPr lang="en-US" dirty="0"/>
-          </a:p>
-          <a:p>
-            <a:pPr marL="0" marR="0" indent="0" algn="l" defTabSz="914400" rtl="0" eaLnBrk="0" fontAlgn="base" latinLnBrk="0" hangingPunct="0">
-              <a:lnSpc>
-                <a:spcPct val="100000"/>
-              </a:lnSpc>
-              <a:spcBef>
-                <a:spcPct val="30000"/>
-              </a:spcBef>
-              <a:spcAft>
-                <a:spcPct val="0"/>
-              </a:spcAft>
-              <a:buClrTx/>
-              <a:buSzTx/>
-              <a:buFontTx/>
-              <a:buNone/>
-              <a:tabLst/>
-              <a:defRPr/>
-            </a:pPr>
-            <a:r>
-              <a:rPr lang="en-US" dirty="0"/>
-              <a:t>(x=y)</a:t>
+              <a:t>’)  which is not a </a:t>
+            </a:r>
+            <a:r>
+              <a:rPr lang="en-US" baseline="0" dirty="0" err="1"/>
+              <a:t>satisfiable</a:t>
             </a:r>
             <a:r>
               <a:rPr lang="en-US" baseline="0" dirty="0"/>
-              <a:t> [y/x][</a:t>
-            </a:r>
-            <a:r>
-              <a:rPr lang="en-US" baseline="0" dirty="0" err="1"/>
-              <a:t>x+y</a:t>
-            </a:r>
-            <a:r>
-              <a:rPr lang="en-US" baseline="0" dirty="0"/>
-              <a:t>/y] </a:t>
-            </a:r>
-            <a:r>
-              <a:rPr lang="en-US" baseline="0" dirty="0">
-                <a:sym typeface="Wingdings"/>
-              </a:rPr>
-              <a:t> </a:t>
-            </a:r>
-            <a:r>
-              <a:rPr lang="en-US" baseline="0" dirty="0" err="1">
-                <a:sym typeface="Wingdings"/>
-              </a:rPr>
-              <a:t>x+y</a:t>
-            </a:r>
-            <a:r>
-              <a:rPr lang="en-US" baseline="0" dirty="0">
-                <a:sym typeface="Wingdings"/>
-              </a:rPr>
-              <a:t>=</a:t>
-            </a:r>
-            <a:r>
-              <a:rPr lang="en-US" baseline="0" dirty="0" err="1">
-                <a:sym typeface="Wingdings"/>
-              </a:rPr>
-              <a:t>x+y</a:t>
-            </a:r>
-            <a:endParaRPr lang="en-US" baseline="0" dirty="0">
-              <a:sym typeface="Wingdings"/>
-            </a:endParaRPr>
-          </a:p>
-          <a:p>
+              <a:t> formula.</a:t>
+            </a:r>
             <a:endParaRPr lang="en-US" dirty="0"/>
           </a:p>
         </p:txBody>
@@ -6316,7 +6389,7 @@
               <a:pPr>
                 <a:defRPr/>
               </a:pPr>
-              <a:t>55</a:t>
+              <a:t>54</a:t>
             </a:fld>
             <a:endParaRPr lang="en-US"/>
           </a:p>
@@ -6325,7 +6398,7 @@
     </p:spTree>
     <p:extLst>
       <p:ext uri="{BB962C8B-B14F-4D97-AF65-F5344CB8AC3E}">
-        <p14:creationId xmlns:p14="http://schemas.microsoft.com/office/powerpoint/2010/main" val="99266755"/>
+        <p14:creationId xmlns:p14="http://schemas.microsoft.com/office/powerpoint/2010/main" val="346693214"/>
       </p:ext>
     </p:extLst>
   </p:cSld>
@@ -6381,118 +6454,110 @@
           <a:p>
             <a:r>
               <a:rPr lang="en-US" dirty="0"/>
-              <a:t>x</a:t>
+              <a:t>(x=y)</a:t>
             </a:r>
             <a:r>
               <a:rPr lang="en-US" baseline="0" dirty="0"/>
-              <a:t> := </a:t>
+              <a:t> [</a:t>
             </a:r>
             <a:r>
               <a:rPr lang="en-US" baseline="0" dirty="0" err="1"/>
-              <a:t>inc</a:t>
+              <a:t>y,x+y</a:t>
             </a:r>
             <a:r>
               <a:rPr lang="en-US" baseline="0" dirty="0"/>
-              <a:t>(x)  </a:t>
-            </a:r>
-          </a:p>
-          <a:p>
-            <a:pPr marL="171450" indent="-171450">
-              <a:buFont typeface="Wingdings" charset="2"/>
-              <a:buChar char="à"/>
-            </a:pPr>
+              <a:t> / </a:t>
+            </a:r>
+            <a:r>
+              <a:rPr lang="en-US" baseline="0" dirty="0" err="1"/>
+              <a:t>x,y</a:t>
+            </a:r>
+            <a:r>
+              <a:rPr lang="en-US" baseline="0" dirty="0"/>
+              <a:t>] </a:t>
+            </a:r>
             <a:r>
               <a:rPr lang="en-US" baseline="0" dirty="0">
                 <a:sym typeface="Wingdings"/>
               </a:rPr>
-              <a:t>transformer to  </a:t>
+              <a:t> y=</a:t>
             </a:r>
             <a:r>
               <a:rPr lang="en-US" baseline="0" dirty="0" err="1">
                 <a:sym typeface="Wingdings"/>
               </a:rPr>
-              <a:t>var</a:t>
+              <a:t>x+y</a:t>
+            </a:r>
+            <a:endParaRPr lang="en-US" baseline="0" dirty="0">
+              <a:sym typeface="Wingdings"/>
+            </a:endParaRPr>
+          </a:p>
+          <a:p>
+            <a:endParaRPr lang="en-US" dirty="0"/>
+          </a:p>
+          <a:p>
+            <a:pPr marL="0" marR="0" indent="0" algn="l" defTabSz="914400" rtl="0" eaLnBrk="0" fontAlgn="base" latinLnBrk="0" hangingPunct="0">
+              <a:lnSpc>
+                <a:spcPct val="100000"/>
+              </a:lnSpc>
+              <a:spcBef>
+                <a:spcPct val="30000"/>
+              </a:spcBef>
+              <a:spcAft>
+                <a:spcPct val="0"/>
+              </a:spcAft>
+              <a:buClrTx/>
+              <a:buSzTx/>
+              <a:buFontTx/>
+              <a:buNone/>
+              <a:tabLst/>
+              <a:defRPr/>
+            </a:pPr>
+            <a:r>
+              <a:rPr lang="en-US" dirty="0"/>
+              <a:t>(x=y)</a:t>
+            </a:r>
+            <a:r>
+              <a:rPr lang="en-US" baseline="0" dirty="0"/>
+              <a:t> [y/x][</a:t>
+            </a:r>
+            <a:r>
+              <a:rPr lang="en-US" baseline="0" dirty="0" err="1"/>
+              <a:t>x+y</a:t>
+            </a:r>
+            <a:r>
+              <a:rPr lang="en-US" baseline="0" dirty="0"/>
+              <a:t>/y] </a:t>
             </a:r>
             <a:r>
               <a:rPr lang="en-US" baseline="0" dirty="0">
                 <a:sym typeface="Wingdings"/>
               </a:rPr>
-              <a:t> x’ , r in x’:=x ; r:=x’+1 ; x:=r end  </a:t>
-            </a:r>
-          </a:p>
-          <a:p>
-            <a:pPr marL="171450" indent="-171450">
-              <a:buFont typeface="Wingdings" charset="2"/>
-              <a:buChar char="à"/>
-            </a:pPr>
+              <a:t> </a:t>
+            </a:r>
             <a:r>
               <a:rPr lang="en-US" baseline="0" dirty="0" err="1">
                 <a:sym typeface="Wingdings"/>
               </a:rPr>
-              <a:t>wlp</a:t>
+              <a:t>x+y</a:t>
             </a:r>
             <a:r>
               <a:rPr lang="en-US" baseline="0" dirty="0">
                 <a:sym typeface="Wingdings"/>
               </a:rPr>
-              <a:t> (...)  x&gt;1</a:t>
-            </a:r>
-            <a:br>
-              <a:rPr lang="en-US" baseline="0" dirty="0">
-                <a:sym typeface="Wingdings"/>
-              </a:rPr>
-            </a:br>
-            <a:r>
-              <a:rPr lang="en-US" baseline="0" dirty="0">
-                <a:sym typeface="Wingdings"/>
-              </a:rPr>
               <a:t>=</a:t>
-            </a:r>
-            <a:br>
-              <a:rPr lang="en-US" baseline="0" dirty="0">
-                <a:sym typeface="Wingdings"/>
-              </a:rPr>
-            </a:br>
-            <a:r>
-              <a:rPr lang="en-US" baseline="0" dirty="0">
-                <a:sym typeface="Wingdings"/>
-              </a:rPr>
-              <a:t>(</a:t>
             </a:r>
             <a:r>
               <a:rPr lang="en-US" baseline="0" dirty="0" err="1">
                 <a:sym typeface="Wingdings"/>
               </a:rPr>
-              <a:t>forall</a:t>
-            </a:r>
-            <a:r>
-              <a:rPr lang="en-US" baseline="0" dirty="0">
-                <a:sym typeface="Wingdings"/>
-              </a:rPr>
-              <a:t> x’ :: x+1&gt;1)</a:t>
-            </a:r>
-            <a:br>
-              <a:rPr lang="en-US" baseline="0" dirty="0">
-                <a:sym typeface="Wingdings"/>
-              </a:rPr>
-            </a:br>
-            <a:r>
-              <a:rPr lang="en-US" baseline="0" dirty="0">
-                <a:sym typeface="Wingdings"/>
-              </a:rPr>
-              <a:t>=</a:t>
-            </a:r>
-            <a:br>
-              <a:rPr lang="en-US" baseline="0" dirty="0">
-                <a:sym typeface="Wingdings"/>
-              </a:rPr>
-            </a:br>
-            <a:r>
-              <a:rPr lang="en-US" baseline="0" dirty="0">
-                <a:sym typeface="Wingdings"/>
-              </a:rPr>
-              <a:t>x+1 &gt; 1</a:t>
-            </a:r>
+              <a:t>x+y</a:t>
+            </a:r>
+            <a:endParaRPr lang="en-US" baseline="0" dirty="0">
+              <a:sym typeface="Wingdings"/>
+            </a:endParaRPr>
+          </a:p>
+          <a:p>
             <a:endParaRPr lang="en-US" dirty="0"/>
           </a:p>
         </p:txBody>
@@ -6520,7 +6585,7 @@
               <a:pPr>
                 <a:defRPr/>
               </a:pPr>
-              <a:t>57</a:t>
+              <a:t>55</a:t>
             </a:fld>
             <a:endParaRPr lang="en-US"/>
           </a:p>
@@ -6529,7 +6594,7 @@
     </p:spTree>
     <p:extLst>
       <p:ext uri="{BB962C8B-B14F-4D97-AF65-F5344CB8AC3E}">
-        <p14:creationId xmlns:p14="http://schemas.microsoft.com/office/powerpoint/2010/main" val="1207166449"/>
+        <p14:creationId xmlns:p14="http://schemas.microsoft.com/office/powerpoint/2010/main" val="99266755"/>
       </p:ext>
     </p:extLst>
   </p:cSld>
@@ -6584,152 +6649,118 @@
           <a:lstStyle/>
           <a:p>
             <a:r>
-              <a:rPr lang="en-US" b="1" dirty="0" err="1">
-                <a:sym typeface="Symbol"/>
+              <a:rPr lang="en-US" dirty="0"/>
+              <a:t>x</a:t>
+            </a:r>
+            <a:r>
+              <a:rPr lang="en-US" baseline="0" dirty="0"/>
+              <a:t> := </a:t>
+            </a:r>
+            <a:r>
+              <a:rPr lang="en-US" baseline="0" dirty="0" err="1"/>
+              <a:t>inc</a:t>
+            </a:r>
+            <a:r>
+              <a:rPr lang="en-US" baseline="0" dirty="0"/>
+              <a:t>(x)  </a:t>
+            </a:r>
+          </a:p>
+          <a:p>
+            <a:pPr marL="171450" indent="-171450">
+              <a:buFont typeface="Wingdings" charset="2"/>
+              <a:buChar char="à"/>
+            </a:pPr>
+            <a:r>
+              <a:rPr lang="en-US" baseline="0" dirty="0">
+                <a:sym typeface="Wingdings"/>
+              </a:rPr>
+              <a:t>transformer to  </a:t>
+            </a:r>
+            <a:r>
+              <a:rPr lang="en-US" baseline="0" dirty="0" err="1">
+                <a:sym typeface="Wingdings"/>
+              </a:rPr>
+              <a:t>var</a:t>
+            </a:r>
+            <a:r>
+              <a:rPr lang="en-US" baseline="0" dirty="0">
+                <a:sym typeface="Wingdings"/>
+              </a:rPr>
+              <a:t> x’ , r in x’:=x ; r:=x’+1 ; x:=r end  </a:t>
+            </a:r>
+          </a:p>
+          <a:p>
+            <a:pPr marL="171450" indent="-171450">
+              <a:buFont typeface="Wingdings" charset="2"/>
+              <a:buChar char="à"/>
+            </a:pPr>
+            <a:r>
+              <a:rPr lang="en-US" baseline="0" dirty="0" err="1">
+                <a:sym typeface="Wingdings"/>
               </a:rPr>
               <a:t>wlp</a:t>
             </a:r>
             <a:r>
-              <a:rPr lang="en-US" dirty="0">
-                <a:sym typeface="Symbol"/>
-              </a:rPr>
-              <a:t>  (</a:t>
-            </a:r>
-            <a:r>
-              <a:rPr lang="en-US" i="1" dirty="0">
-                <a:sym typeface="Symbol"/>
-              </a:rPr>
-              <a:t>x</a:t>
-            </a:r>
-            <a:r>
-              <a:rPr lang="en-US" dirty="0">
-                <a:sym typeface="Symbol"/>
-              </a:rPr>
-              <a:t> := </a:t>
-            </a:r>
-            <a:r>
-              <a:rPr lang="en-US" i="1" dirty="0">
-                <a:sym typeface="Symbol"/>
-              </a:rPr>
-              <a:t>drop</a:t>
-            </a:r>
-            <a:r>
-              <a:rPr lang="en-US" dirty="0">
-                <a:sym typeface="Symbol"/>
+              <a:rPr lang="en-US" baseline="0" dirty="0">
+                <a:sym typeface="Wingdings"/>
+              </a:rPr>
+              <a:t> (...)  x&gt;1</a:t>
+            </a:r>
+            <a:br>
+              <a:rPr lang="en-US" baseline="0" dirty="0">
+                <a:sym typeface="Wingdings"/>
+              </a:rPr>
+            </a:br>
+            <a:r>
+              <a:rPr lang="en-US" baseline="0" dirty="0">
+                <a:sym typeface="Wingdings"/>
+              </a:rPr>
+              <a:t>=</a:t>
+            </a:r>
+            <a:br>
+              <a:rPr lang="en-US" baseline="0" dirty="0">
+                <a:sym typeface="Wingdings"/>
+              </a:rPr>
+            </a:br>
+            <a:r>
+              <a:rPr lang="en-US" baseline="0" dirty="0">
+                <a:sym typeface="Wingdings"/>
               </a:rPr>
               <a:t>(</a:t>
             </a:r>
             <a:r>
-              <a:rPr lang="en-US" i="1" dirty="0">
-                <a:sym typeface="Symbol"/>
-              </a:rPr>
-              <a:t>x</a:t>
-            </a:r>
-            <a:r>
-              <a:rPr lang="en-US" dirty="0">
-                <a:sym typeface="Symbol"/>
-              </a:rPr>
-              <a:t>))   (</a:t>
-            </a:r>
-            <a:r>
-              <a:rPr lang="en-US" i="1" dirty="0">
-                <a:sym typeface="Symbol"/>
-              </a:rPr>
-              <a:t>x</a:t>
-            </a:r>
-            <a:r>
-              <a:rPr lang="en-US" dirty="0">
-                <a:sym typeface="Symbol"/>
-              </a:rPr>
-              <a:t>&lt;7)  </a:t>
+              <a:rPr lang="en-US" baseline="0" dirty="0" err="1">
+                <a:sym typeface="Wingdings"/>
+              </a:rPr>
+              <a:t>forall</a:t>
+            </a:r>
+            <a:r>
+              <a:rPr lang="en-US" baseline="0" dirty="0">
+                <a:sym typeface="Wingdings"/>
+              </a:rPr>
+              <a:t> x’ :: x+1&gt;1)</a:t>
             </a:r>
             <a:br>
-              <a:rPr lang="en-US" dirty="0">
-                <a:sym typeface="Symbol"/>
+              <a:rPr lang="en-US" baseline="0" dirty="0">
+                <a:sym typeface="Wingdings"/>
               </a:rPr>
             </a:br>
-            <a:endParaRPr lang="en-US" dirty="0">
-              <a:sym typeface="Symbol"/>
-            </a:endParaRPr>
-          </a:p>
-          <a:p>
-            <a:r>
-              <a:rPr lang="en-US" dirty="0">
-                <a:sym typeface="Symbol"/>
-              </a:rPr>
-              <a:t>= </a:t>
-            </a:r>
-          </a:p>
-          <a:p>
-            <a:r>
-              <a:rPr lang="en-US" dirty="0" err="1">
-                <a:sym typeface="Symbol"/>
-              </a:rPr>
-              <a:t>wlp</a:t>
-            </a:r>
-            <a:r>
-              <a:rPr lang="en-US" dirty="0">
-                <a:sym typeface="Symbol"/>
-              </a:rPr>
-              <a:t> (</a:t>
-            </a:r>
-            <a:r>
-              <a:rPr lang="en-US" dirty="0" err="1">
-                <a:sym typeface="Symbol"/>
-              </a:rPr>
-              <a:t>var</a:t>
-            </a:r>
-            <a:r>
-              <a:rPr lang="en-US" dirty="0">
-                <a:sym typeface="Symbol"/>
-              </a:rPr>
-              <a:t> </a:t>
-            </a:r>
-            <a:r>
-              <a:rPr lang="en-US" dirty="0" err="1">
-                <a:sym typeface="Symbol"/>
-              </a:rPr>
-              <a:t>x’,r</a:t>
-            </a:r>
-            <a:r>
-              <a:rPr lang="en-US" dirty="0">
-                <a:sym typeface="Symbol"/>
-              </a:rPr>
-              <a:t> in x’ := x</a:t>
-            </a:r>
             <a:r>
               <a:rPr lang="en-US" baseline="0" dirty="0">
-                <a:sym typeface="Symbol"/>
-              </a:rPr>
-              <a:t> ; assert x’&gt;0 ; assume r&lt;x’ ; x := r)  x&lt;7</a:t>
-            </a:r>
-          </a:p>
-          <a:p>
-            <a:r>
+                <a:sym typeface="Wingdings"/>
+              </a:rPr>
+              <a:t>=</a:t>
+            </a:r>
+            <a:br>
               <a:rPr lang="en-US" baseline="0" dirty="0">
-                <a:sym typeface="Symbol"/>
-              </a:rPr>
-              <a:t>=</a:t>
-            </a:r>
-          </a:p>
-          <a:p>
+                <a:sym typeface="Wingdings"/>
+              </a:rPr>
+            </a:br>
             <a:r>
               <a:rPr lang="en-US" baseline="0" dirty="0">
-                <a:sym typeface="Symbol"/>
-              </a:rPr>
-              <a:t>(</a:t>
-            </a:r>
-            <a:r>
-              <a:rPr lang="en-US" baseline="0" dirty="0" err="1">
-                <a:sym typeface="Symbol"/>
-              </a:rPr>
-              <a:t>Forall</a:t>
-            </a:r>
-            <a:r>
-              <a:rPr lang="en-US" baseline="0" dirty="0">
-                <a:sym typeface="Symbol"/>
-              </a:rPr>
-              <a:t> r :: x&gt;0 /\ (r&lt;x  =&gt; r&lt;7))</a:t>
+                <a:sym typeface="Wingdings"/>
+              </a:rPr>
+              <a:t>x+1 &gt; 1</a:t>
             </a:r>
             <a:endParaRPr lang="en-US" dirty="0"/>
           </a:p>
@@ -6758,7 +6789,7 @@
               <a:pPr>
                 <a:defRPr/>
               </a:pPr>
-              <a:t>58</a:t>
+              <a:t>57</a:t>
             </a:fld>
             <a:endParaRPr lang="en-US"/>
           </a:p>
@@ -6767,7 +6798,7 @@
     </p:spTree>
     <p:extLst>
       <p:ext uri="{BB962C8B-B14F-4D97-AF65-F5344CB8AC3E}">
-        <p14:creationId xmlns:p14="http://schemas.microsoft.com/office/powerpoint/2010/main" val="1348243107"/>
+        <p14:creationId xmlns:p14="http://schemas.microsoft.com/office/powerpoint/2010/main" val="1207166449"/>
       </p:ext>
     </p:extLst>
   </p:cSld>
@@ -6821,6 +6852,154 @@
           <a:bodyPr/>
           <a:lstStyle/>
           <a:p>
+            <a:r>
+              <a:rPr lang="en-US" b="1" dirty="0" err="1">
+                <a:sym typeface="Symbol"/>
+              </a:rPr>
+              <a:t>wlp</a:t>
+            </a:r>
+            <a:r>
+              <a:rPr lang="en-US" dirty="0">
+                <a:sym typeface="Symbol"/>
+              </a:rPr>
+              <a:t>  (</a:t>
+            </a:r>
+            <a:r>
+              <a:rPr lang="en-US" i="1" dirty="0">
+                <a:sym typeface="Symbol"/>
+              </a:rPr>
+              <a:t>x</a:t>
+            </a:r>
+            <a:r>
+              <a:rPr lang="en-US" dirty="0">
+                <a:sym typeface="Symbol"/>
+              </a:rPr>
+              <a:t> := </a:t>
+            </a:r>
+            <a:r>
+              <a:rPr lang="en-US" i="1" dirty="0">
+                <a:sym typeface="Symbol"/>
+              </a:rPr>
+              <a:t>drop</a:t>
+            </a:r>
+            <a:r>
+              <a:rPr lang="en-US" dirty="0">
+                <a:sym typeface="Symbol"/>
+              </a:rPr>
+              <a:t>(</a:t>
+            </a:r>
+            <a:r>
+              <a:rPr lang="en-US" i="1" dirty="0">
+                <a:sym typeface="Symbol"/>
+              </a:rPr>
+              <a:t>x</a:t>
+            </a:r>
+            <a:r>
+              <a:rPr lang="en-US" dirty="0">
+                <a:sym typeface="Symbol"/>
+              </a:rPr>
+              <a:t>))   (</a:t>
+            </a:r>
+            <a:r>
+              <a:rPr lang="en-US" i="1" dirty="0">
+                <a:sym typeface="Symbol"/>
+              </a:rPr>
+              <a:t>x</a:t>
+            </a:r>
+            <a:r>
+              <a:rPr lang="en-US" dirty="0">
+                <a:sym typeface="Symbol"/>
+              </a:rPr>
+              <a:t>&lt;7)  </a:t>
+            </a:r>
+            <a:br>
+              <a:rPr lang="en-US" dirty="0">
+                <a:sym typeface="Symbol"/>
+              </a:rPr>
+            </a:br>
+            <a:endParaRPr lang="en-US" dirty="0">
+              <a:sym typeface="Symbol"/>
+            </a:endParaRPr>
+          </a:p>
+          <a:p>
+            <a:r>
+              <a:rPr lang="en-US" dirty="0">
+                <a:sym typeface="Symbol"/>
+              </a:rPr>
+              <a:t>= </a:t>
+            </a:r>
+          </a:p>
+          <a:p>
+            <a:r>
+              <a:rPr lang="en-US" dirty="0" err="1">
+                <a:sym typeface="Symbol"/>
+              </a:rPr>
+              <a:t>wlp</a:t>
+            </a:r>
+            <a:r>
+              <a:rPr lang="en-US" dirty="0">
+                <a:sym typeface="Symbol"/>
+              </a:rPr>
+              <a:t> (</a:t>
+            </a:r>
+            <a:r>
+              <a:rPr lang="en-US" dirty="0" err="1">
+                <a:sym typeface="Symbol"/>
+              </a:rPr>
+              <a:t>var</a:t>
+            </a:r>
+            <a:r>
+              <a:rPr lang="en-US" dirty="0">
+                <a:sym typeface="Symbol"/>
+              </a:rPr>
+              <a:t> </a:t>
+            </a:r>
+            <a:r>
+              <a:rPr lang="en-US" dirty="0" err="1">
+                <a:sym typeface="Symbol"/>
+              </a:rPr>
+              <a:t>x’,r</a:t>
+            </a:r>
+            <a:r>
+              <a:rPr lang="en-US" dirty="0">
+                <a:sym typeface="Symbol"/>
+              </a:rPr>
+              <a:t> in x’ := x</a:t>
+            </a:r>
+            <a:r>
+              <a:rPr lang="en-US" baseline="0" dirty="0">
+                <a:sym typeface="Symbol"/>
+              </a:rPr>
+              <a:t> ; assert x’&gt;0 ; assume r&lt;x’ ; x := r)  x&lt;7</a:t>
+            </a:r>
+          </a:p>
+          <a:p>
+            <a:r>
+              <a:rPr lang="en-US" baseline="0" dirty="0">
+                <a:sym typeface="Symbol"/>
+              </a:rPr>
+              <a:t>=</a:t>
+            </a:r>
+          </a:p>
+          <a:p>
+            <a:r>
+              <a:rPr lang="en-US" baseline="0" dirty="0">
+                <a:sym typeface="Symbol"/>
+              </a:rPr>
+              <a:t>(</a:t>
+            </a:r>
+            <a:r>
+              <a:rPr lang="en-US" baseline="0" dirty="0" err="1">
+                <a:sym typeface="Symbol"/>
+              </a:rPr>
+              <a:t>Forall</a:t>
+            </a:r>
+            <a:r>
+              <a:rPr lang="en-US" baseline="0" dirty="0">
+                <a:sym typeface="Symbol"/>
+              </a:rPr>
+              <a:t> r :: x&gt;0 /\ (r&lt;x  =&gt; r&lt;7))</a:t>
+            </a:r>
             <a:endParaRPr lang="en-US" dirty="0"/>
           </a:p>
         </p:txBody>
@@ -6848,7 +7027,7 @@
               <a:pPr>
                 <a:defRPr/>
               </a:pPr>
-              <a:t>64</a:t>
+              <a:t>58</a:t>
             </a:fld>
             <a:endParaRPr lang="en-US"/>
           </a:p>
@@ -6857,7 +7036,7 @@
     </p:spTree>
     <p:extLst>
       <p:ext uri="{BB962C8B-B14F-4D97-AF65-F5344CB8AC3E}">
-        <p14:creationId xmlns:p14="http://schemas.microsoft.com/office/powerpoint/2010/main" val="578913574"/>
+        <p14:creationId xmlns:p14="http://schemas.microsoft.com/office/powerpoint/2010/main" val="1348243107"/>
       </p:ext>
     </p:extLst>
   </p:cSld>
@@ -6908,6 +7087,96 @@
         </p:nvSpPr>
         <p:spPr/>
         <p:txBody>
+          <a:bodyPr/>
+          <a:lstStyle/>
+          <a:p>
+            <a:endParaRPr lang="en-US" dirty="0"/>
+          </a:p>
+        </p:txBody>
+      </p:sp>
+      <p:sp>
+        <p:nvSpPr>
+          <p:cNvPr id="4" name="Slide Number Placeholder 3"/>
+          <p:cNvSpPr>
+            <a:spLocks noGrp="1"/>
+          </p:cNvSpPr>
+          <p:nvPr>
+            <p:ph type="sldNum" sz="quarter" idx="10"/>
+          </p:nvPr>
+        </p:nvSpPr>
+        <p:spPr/>
+        <p:txBody>
+          <a:bodyPr/>
+          <a:lstStyle/>
+          <a:p>
+            <a:pPr>
+              <a:defRPr/>
+            </a:pPr>
+            <a:fld id="{CA39CDBC-8017-4E8F-B9B6-0F2C75591882}" type="slidenum">
+              <a:rPr lang="en-US" smtClean="0"/>
+              <a:pPr>
+                <a:defRPr/>
+              </a:pPr>
+              <a:t>64</a:t>
+            </a:fld>
+            <a:endParaRPr lang="en-US"/>
+          </a:p>
+        </p:txBody>
+      </p:sp>
+    </p:spTree>
+    <p:extLst>
+      <p:ext uri="{BB962C8B-B14F-4D97-AF65-F5344CB8AC3E}">
+        <p14:creationId xmlns:p14="http://schemas.microsoft.com/office/powerpoint/2010/main" val="578913574"/>
+      </p:ext>
+    </p:extLst>
+  </p:cSld>
+  <p:clrMapOvr>
+    <a:masterClrMapping/>
+  </p:clrMapOvr>
+</p:notes>
+</file>
+
+<file path=ppt/notesSlides/notesSlide48.xml><?xml version="1.0" encoding="utf-8"?>
+<p:notes xmlns:a="http://schemas.openxmlformats.org/drawingml/2006/main" xmlns:r="http://schemas.openxmlformats.org/officeDocument/2006/relationships" xmlns:p="http://schemas.openxmlformats.org/presentationml/2006/main">
+  <p:cSld>
+    <p:spTree>
+      <p:nvGrpSpPr>
+        <p:cNvPr id="1" name=""/>
+        <p:cNvGrpSpPr/>
+        <p:nvPr/>
+      </p:nvGrpSpPr>
+      <p:grpSpPr>
+        <a:xfrm>
+          <a:off x="0" y="0"/>
+          <a:ext cx="0" cy="0"/>
+          <a:chOff x="0" y="0"/>
+          <a:chExt cx="0" cy="0"/>
+        </a:xfrm>
+      </p:grpSpPr>
+      <p:sp>
+        <p:nvSpPr>
+          <p:cNvPr id="2" name="Slide Image Placeholder 1"/>
+          <p:cNvSpPr>
+            <a:spLocks noGrp="1" noRot="1" noChangeAspect="1"/>
+          </p:cNvSpPr>
+          <p:nvPr>
+            <p:ph type="sldImg"/>
+          </p:nvPr>
+        </p:nvSpPr>
+        <p:spPr/>
+      </p:sp>
+      <p:sp>
+        <p:nvSpPr>
+          <p:cNvPr id="3" name="Notes Placeholder 2"/>
+          <p:cNvSpPr>
+            <a:spLocks noGrp="1"/>
+          </p:cNvSpPr>
+          <p:nvPr>
+            <p:ph type="body" idx="1"/>
+          </p:nvPr>
+        </p:nvSpPr>
+        <p:spPr/>
+        <p:txBody>
           <a:bodyPr>
             <a:normAutofit/>
           </a:bodyPr>
@@ -7074,7 +7343,7 @@
 </p:notes>
 </file>
 
-<file path=ppt/notesSlides/notesSlide48.xml><?xml version="1.0" encoding="utf-8"?>
+<file path=ppt/notesSlides/notesSlide49.xml><?xml version="1.0" encoding="utf-8"?>
 <p:notes xmlns:a="http://schemas.openxmlformats.org/drawingml/2006/main" xmlns:r="http://schemas.openxmlformats.org/officeDocument/2006/relationships" xmlns:p="http://schemas.openxmlformats.org/presentationml/2006/main">
   <p:cSld>
     <p:spTree>
@@ -33921,7 +34190,7 @@
               <a:rPr lang="nl-NL" dirty="0">
                 <a:sym typeface="Symbol"/>
               </a:rPr>
-              <a:t> </a:t>
+              <a:t></a:t>
             </a:r>
             <a:r>
               <a:rPr lang="nl-NL" baseline="30000" dirty="0"/>
@@ -34010,7 +34279,27 @@
           <a:p>
             <a:r>
               <a:rPr lang="nl-NL" dirty="0"/>
-              <a:t>Iterate at most </a:t>
+              <a:t>[</a:t>
+            </a:r>
+            <a:r>
+              <a:rPr lang="nl-NL" b="1" dirty="0" err="1"/>
+              <a:t>while</a:t>
+            </a:r>
+            <a:r>
+              <a:rPr lang="nl-NL" dirty="0"/>
+              <a:t>]</a:t>
+            </a:r>
+            <a:r>
+              <a:rPr lang="nl-NL" baseline="30000" dirty="0"/>
+              <a:t>k  </a:t>
+            </a:r>
+            <a:r>
+              <a:rPr lang="nl-NL" dirty="0" err="1"/>
+              <a:t>iterates</a:t>
+            </a:r>
+            <a:r>
+              <a:rPr lang="nl-NL" dirty="0"/>
+              <a:t> at most </a:t>
             </a:r>
             <a:r>
               <a:rPr lang="nl-NL" i="1" dirty="0"/>
@@ -34018,13 +34307,61 @@
             </a:r>
             <a:r>
               <a:rPr lang="nl-NL" dirty="0"/>
-              <a:t>-times. </a:t>
-            </a:r>
-          </a:p>
-          <a:p>
-            <a:r>
-              <a:rPr lang="en-US" dirty="0"/>
-              <a:t>Iterate at most </a:t>
+              <a:t>-</a:t>
+            </a:r>
+            <a:r>
+              <a:rPr lang="nl-NL" dirty="0" err="1"/>
+              <a:t>times</a:t>
+            </a:r>
+            <a:r>
+              <a:rPr lang="nl-NL" dirty="0"/>
+              <a:t>, </a:t>
+            </a:r>
+            <a:r>
+              <a:rPr lang="nl-NL" dirty="0" err="1"/>
+              <a:t>then</a:t>
+            </a:r>
+            <a:r>
+              <a:rPr lang="nl-NL" dirty="0"/>
+              <a:t> </a:t>
+            </a:r>
+            <a:r>
+              <a:rPr lang="nl-NL" dirty="0" err="1"/>
+              <a:t>stops</a:t>
+            </a:r>
+            <a:r>
+              <a:rPr lang="nl-NL" dirty="0"/>
+              <a:t>.</a:t>
+            </a:r>
+          </a:p>
+          <a:p>
+            <a:r>
+              <a:rPr lang="nl-NL" dirty="0">
+                <a:sym typeface="Symbol"/>
+              </a:rPr>
+              <a:t></a:t>
+            </a:r>
+            <a:r>
+              <a:rPr lang="nl-NL" b="1" dirty="0" err="1"/>
+              <a:t>while</a:t>
+            </a:r>
+            <a:r>
+              <a:rPr lang="nl-NL" dirty="0" err="1">
+                <a:sym typeface="Symbol"/>
+              </a:rPr>
+              <a:t></a:t>
+            </a:r>
+            <a:r>
+              <a:rPr lang="nl-NL" baseline="30000" dirty="0" err="1"/>
+              <a:t>k</a:t>
+            </a:r>
+            <a:r>
+              <a:rPr lang="nl-NL" baseline="30000" dirty="0"/>
+              <a:t>  </a:t>
+            </a:r>
+            <a:r>
+              <a:rPr lang="en-US" dirty="0"/>
+              <a:t>iterates at most </a:t>
             </a:r>
             <a:r>
               <a:rPr lang="en-US" i="1" dirty="0"/>
@@ -34032,13 +34369,7 @@
             </a:r>
             <a:r>
               <a:rPr lang="en-US" dirty="0"/>
-              <a:t>times, then </a:t>
-            </a:r>
-            <a:r>
-              <a:rPr lang="en-US" dirty="0">
-                <a:sym typeface="Wingdings" pitchFamily="2" charset="2"/>
-              </a:rPr>
-              <a:t>miracle.</a:t>
+              <a:t>times; higher iterations are ignored/removed.</a:t>
             </a:r>
             <a:endParaRPr lang="nl-NL" dirty="0"/>
           </a:p>
@@ -38488,7 +38819,7 @@
         <p:spPr/>
         <p:txBody>
           <a:bodyPr>
-            <a:normAutofit fontScale="92500" lnSpcReduction="10000"/>
+            <a:normAutofit fontScale="92500"/>
           </a:bodyPr>
           <a:lstStyle/>
           <a:p>
@@ -38540,7 +38871,7 @@
               <a:rPr lang="en-US" dirty="0">
                 <a:sym typeface="Symbol"/>
               </a:rPr>
-              <a:t>Two types of values : primitive values, or reference to another object.</a:t>
+              <a:t>Two types of values : primitive values, or reference to an object.</a:t>
             </a:r>
           </a:p>
           <a:p>
@@ -38995,6 +39326,14 @@
               <a:rPr lang="en-US" sz="2000" dirty="0"/>
               <a:t>) representing the desired situation when a program terminates normally, and when it terminates exceptionally.</a:t>
             </a:r>
+          </a:p>
+          <a:p>
+            <a:pPr lvl="1"/>
+            <a:r>
+              <a:rPr lang="en-US" dirty="0"/>
+              <a:t>Approach-3: represent a program as a control flow graph</a:t>
+            </a:r>
+            <a:endParaRPr lang="en-US" sz="2000" dirty="0"/>
           </a:p>
           <a:p>
             <a:endParaRPr lang="en-US" sz="2400" dirty="0"/>
@@ -39300,7 +39639,7 @@
         <p:spPr>
           <a:xfrm>
             <a:off x="500034" y="1714500"/>
-            <a:ext cx="8358246" cy="4305300"/>
+            <a:ext cx="8358246" cy="4723878"/>
           </a:xfrm>
         </p:spPr>
         <p:txBody>
@@ -39420,143 +39759,63 @@
               <a:buNone/>
             </a:pPr>
             <a:r>
-              <a:rPr lang="en-US" dirty="0">
-                <a:sym typeface="Wingdings" pitchFamily="2" charset="2"/>
-              </a:rPr>
-              <a:t>Can we avoid that?</a:t>
-            </a:r>
-            <a:endParaRPr lang="en-US" dirty="0"/>
-          </a:p>
-          <a:p>
-            <a:pPr lvl="1"/>
-            <a:r>
-              <a:rPr lang="en-US" dirty="0"/>
+              <a:rPr lang="en-US" sz="2400" dirty="0"/>
               <a:t>We can optimize this by statically checking if </a:t>
             </a:r>
             <a:r>
-              <a:rPr lang="en-US" dirty="0" err="1"/>
+              <a:rPr lang="en-US" sz="2400" dirty="0" err="1"/>
               <a:t>exc</a:t>
             </a:r>
             <a:r>
-              <a:rPr lang="en-US" dirty="0"/>
+              <a:rPr lang="en-US" sz="2400" dirty="0"/>
               <a:t> would be true after S</a:t>
             </a:r>
             <a:r>
-              <a:rPr lang="en-US" baseline="-25000" dirty="0"/>
+              <a:rPr lang="en-US" sz="2400" baseline="-25000" dirty="0"/>
               <a:t>1</a:t>
             </a:r>
             <a:r>
-              <a:rPr lang="en-US" dirty="0"/>
+              <a:rPr lang="en-US" sz="2400" dirty="0"/>
               <a:t>. If so, there is no need to expand S</a:t>
             </a:r>
             <a:r>
-              <a:rPr lang="en-US" baseline="-25000" dirty="0"/>
+              <a:rPr lang="en-US" sz="2400" baseline="-25000" dirty="0"/>
               <a:t>2</a:t>
             </a:r>
             <a:r>
-              <a:rPr lang="en-US" dirty="0"/>
-              <a:t>.</a:t>
-            </a:r>
-          </a:p>
-          <a:p>
-            <a:pPr lvl="1"/>
-            <a:r>
-              <a:rPr lang="en-US" dirty="0">
-                <a:sym typeface="Wingdings" pitchFamily="2" charset="2"/>
-              </a:rPr>
-              <a:t>Caution: what should we do with “</a:t>
-            </a:r>
-            <a:r>
-              <a:rPr lang="en-US" b="1" dirty="0">
-                <a:highlight>
-                  <a:srgbClr val="FFFF00"/>
-                </a:highlight>
-                <a:sym typeface="Wingdings" pitchFamily="2" charset="2"/>
-              </a:rPr>
-              <a:t>if</a:t>
-            </a:r>
-            <a:r>
-              <a:rPr lang="en-US" dirty="0">
-                <a:highlight>
-                  <a:srgbClr val="FFFF00"/>
-                </a:highlight>
-                <a:sym typeface="Wingdings" pitchFamily="2" charset="2"/>
-              </a:rPr>
-              <a:t> g </a:t>
-            </a:r>
-            <a:r>
-              <a:rPr lang="en-US" b="1" dirty="0">
-                <a:highlight>
-                  <a:srgbClr val="FFFF00"/>
-                </a:highlight>
-                <a:sym typeface="Wingdings" pitchFamily="2" charset="2"/>
-              </a:rPr>
-              <a:t>then</a:t>
-            </a:r>
-            <a:r>
-              <a:rPr lang="en-US" dirty="0">
-                <a:highlight>
-                  <a:srgbClr val="FFFF00"/>
-                </a:highlight>
-                <a:sym typeface="Wingdings" pitchFamily="2" charset="2"/>
-              </a:rPr>
-              <a:t> </a:t>
-            </a:r>
-            <a:r>
-              <a:rPr lang="en-US" dirty="0">
-                <a:solidFill>
-                  <a:srgbClr val="C00000"/>
-                </a:solidFill>
-                <a:highlight>
-                  <a:srgbClr val="FFFF00"/>
-                </a:highlight>
-                <a:sym typeface="Wingdings" pitchFamily="2" charset="2"/>
-              </a:rPr>
-              <a:t>raise</a:t>
-            </a:r>
-            <a:r>
-              <a:rPr lang="en-US" dirty="0">
-                <a:highlight>
-                  <a:srgbClr val="FFFF00"/>
-                </a:highlight>
-                <a:sym typeface="Wingdings" pitchFamily="2" charset="2"/>
-              </a:rPr>
-              <a:t> </a:t>
-            </a:r>
-            <a:r>
-              <a:rPr lang="en-US" b="1" dirty="0">
-                <a:highlight>
-                  <a:srgbClr val="FFFF00"/>
-                </a:highlight>
-                <a:sym typeface="Wingdings" pitchFamily="2" charset="2"/>
-              </a:rPr>
-              <a:t>else</a:t>
-            </a:r>
-            <a:r>
-              <a:rPr lang="en-US" dirty="0">
-                <a:highlight>
-                  <a:srgbClr val="FFFF00"/>
-                </a:highlight>
-                <a:sym typeface="Wingdings" pitchFamily="2" charset="2"/>
-              </a:rPr>
-              <a:t> skip </a:t>
-            </a:r>
-            <a:r>
-              <a:rPr lang="en-US" dirty="0">
-                <a:highlight>
-                  <a:srgbClr val="00FFFF"/>
-                </a:highlight>
-                <a:sym typeface="Wingdings" pitchFamily="2" charset="2"/>
-              </a:rPr>
-              <a:t>; S</a:t>
-            </a:r>
-            <a:r>
-              <a:rPr lang="en-US" dirty="0">
-                <a:sym typeface="Wingdings" pitchFamily="2" charset="2"/>
-              </a:rPr>
-              <a:t>” ?</a:t>
-            </a:r>
-            <a:endParaRPr lang="en-US" b="1" dirty="0"/>
+              <a:rPr lang="en-US" sz="2400" dirty="0"/>
+              <a:t>.  Examples:</a:t>
+            </a:r>
+          </a:p>
+          <a:p>
+            <a:pPr lvl="2"/>
+            <a:r>
+              <a:rPr lang="en-US" sz="2400" dirty="0"/>
+              <a:t>S</a:t>
+            </a:r>
+            <a:r>
+              <a:rPr lang="en-US" sz="2400" baseline="-25000" dirty="0"/>
+              <a:t>1</a:t>
+            </a:r>
+            <a:r>
+              <a:rPr lang="en-US" sz="2400" dirty="0"/>
+              <a:t> does not  contain any raise stmt.</a:t>
+            </a:r>
+          </a:p>
+          <a:p>
+            <a:pPr lvl="2"/>
+            <a:r>
+              <a:rPr lang="en-US" sz="2400" dirty="0"/>
+              <a:t>S</a:t>
+            </a:r>
+            <a:r>
+              <a:rPr lang="en-US" sz="2400" baseline="-25000" dirty="0"/>
+              <a:t>1</a:t>
+            </a:r>
+            <a:r>
+              <a:rPr lang="en-US" sz="2400" dirty="0"/>
+              <a:t> is enclosed by an exception handler, that does not contain raise.</a:t>
+            </a:r>
           </a:p>
           <a:p>
             <a:r>
@@ -39567,9 +39826,6 @@
               <a:rPr lang="en-US" dirty="0"/>
               <a:t>also need to be transformed due to the implicit sequencing  between iterations</a:t>
             </a:r>
-          </a:p>
-          <a:p>
-            <a:endParaRPr lang="en-US" i="1" dirty="0"/>
           </a:p>
         </p:txBody>
       </p:sp>
@@ -41392,6 +41648,10 @@
             </a:r>
           </a:p>
           <a:p>
+            <a:pPr lvl="1"/>
+            <a:endParaRPr lang="en-US" dirty="0"/>
+          </a:p>
+          <a:p>
             <a:r>
               <a:rPr lang="en-US" dirty="0"/>
               <a:t>Approach 2:</a:t>
@@ -41405,78 +41665,28 @@
             </a:r>
           </a:p>
           <a:p>
-            <a:r>
-              <a:rPr lang="en-US" b="1" dirty="0">
-                <a:highlight>
-                  <a:srgbClr val="FFFF00"/>
-                </a:highlight>
-              </a:rPr>
-              <a:t>If</a:t>
-            </a:r>
-            <a:r>
-              <a:rPr lang="en-US" dirty="0">
-                <a:highlight>
-                  <a:srgbClr val="FFFF00"/>
-                </a:highlight>
-              </a:rPr>
-              <a:t> g </a:t>
-            </a:r>
-            <a:r>
-              <a:rPr lang="en-US" b="1" dirty="0">
-                <a:highlight>
-                  <a:srgbClr val="FFFF00"/>
-                </a:highlight>
-              </a:rPr>
-              <a:t>then</a:t>
-            </a:r>
-            <a:r>
-              <a:rPr lang="en-US" dirty="0">
-                <a:highlight>
-                  <a:srgbClr val="FFFF00"/>
-                </a:highlight>
-              </a:rPr>
-              <a:t> raise </a:t>
-            </a:r>
-            <a:r>
-              <a:rPr lang="en-US" b="1" dirty="0">
-                <a:highlight>
-                  <a:srgbClr val="FFFF00"/>
-                </a:highlight>
-              </a:rPr>
-              <a:t>else</a:t>
-            </a:r>
-            <a:r>
-              <a:rPr lang="en-US" dirty="0">
-                <a:highlight>
-                  <a:srgbClr val="FFFF00"/>
-                </a:highlight>
-              </a:rPr>
-              <a:t> skip </a:t>
-            </a:r>
-            <a:r>
-              <a:rPr lang="en-US" dirty="0">
-                <a:highlight>
-                  <a:srgbClr val="00FFFF"/>
-                </a:highlight>
-              </a:rPr>
-              <a:t>; S </a:t>
-            </a:r>
-            <a:r>
-              <a:rPr lang="en-US" dirty="0"/>
-              <a:t>     </a:t>
-            </a:r>
-            <a:r>
-              <a:rPr lang="en-US" dirty="0">
-                <a:sym typeface="Wingdings" pitchFamily="2" charset="2"/>
-              </a:rPr>
-              <a:t>  needs some pre-processing to avoid blow up.</a:t>
-            </a:r>
+            <a:pPr lvl="1"/>
             <a:endParaRPr lang="en-US" dirty="0"/>
           </a:p>
           <a:p>
             <a:r>
               <a:rPr lang="en-US" dirty="0"/>
               <a:t>To consider: using a control flow graph.</a:t>
+            </a:r>
+          </a:p>
+          <a:p>
+            <a:pPr lvl="1"/>
+            <a:r>
+              <a:rPr lang="en-US" dirty="0"/>
+              <a:t>But </a:t>
+            </a:r>
+            <a:r>
+              <a:rPr lang="en-US" dirty="0" err="1"/>
+              <a:t>wlp</a:t>
+            </a:r>
+            <a:r>
+              <a:rPr lang="en-US" dirty="0"/>
+              <a:t> is then no longer syntax driven.</a:t>
             </a:r>
           </a:p>
         </p:txBody>

</xml_diff>

<commit_message>
adding def update to slides hoare
</commit_message>
<xml_diff>
--- a/slides/PV_hoare.pptx
+++ b/slides/PV_hoare.pptx
@@ -25592,7 +25592,9 @@
         </p:nvSpPr>
         <p:spPr/>
         <p:txBody>
-          <a:bodyPr/>
+          <a:bodyPr>
+            <a:normAutofit lnSpcReduction="10000"/>
+          </a:bodyPr>
           <a:lstStyle/>
           <a:p>
             <a:r>
@@ -25720,6 +25722,88 @@
             <a:r>
               <a:rPr lang="en-US" dirty="0"/>
               <a:t>⟧ s) )</a:t>
+            </a:r>
+            <a:br>
+              <a:rPr lang="en-US" dirty="0"/>
+            </a:br>
+            <a:br>
+              <a:rPr lang="en-US" dirty="0"/>
+            </a:br>
+            <a:r>
+              <a:rPr lang="en-US" dirty="0"/>
+              <a:t>where: </a:t>
+            </a:r>
+            <a:r>
+              <a:rPr lang="en-US" b="1" dirty="0"/>
+              <a:t>update</a:t>
+            </a:r>
+            <a:r>
+              <a:rPr lang="en-US" dirty="0"/>
+              <a:t> s x = (𝜆</a:t>
+            </a:r>
+            <a:r>
+              <a:rPr lang="en-US" i="1" dirty="0" err="1"/>
+              <a:t>varname</a:t>
+            </a:r>
+            <a:r>
+              <a:rPr lang="en-US" dirty="0"/>
+              <a:t>. </a:t>
+            </a:r>
+            <a:r>
+              <a:rPr lang="en-US" b="1" dirty="0"/>
+              <a:t>if</a:t>
+            </a:r>
+            <a:r>
+              <a:rPr lang="en-US" dirty="0"/>
+              <a:t> </a:t>
+            </a:r>
+            <a:r>
+              <a:rPr lang="en-US" i="1" dirty="0" err="1"/>
+              <a:t>varname</a:t>
+            </a:r>
+            <a:r>
+              <a:rPr lang="en-US" dirty="0"/>
+              <a:t>=x </a:t>
+            </a:r>
+            <a:r>
+              <a:rPr lang="en-US" b="1" dirty="0"/>
+              <a:t>then</a:t>
+            </a:r>
+            <a:r>
+              <a:rPr lang="en-US" dirty="0"/>
+              <a:t> </a:t>
+            </a:r>
+            <a:r>
+              <a:rPr lang="en-US" dirty="0" err="1">
+                <a:solidFill>
+                  <a:srgbClr val="C00000"/>
+                </a:solidFill>
+              </a:rPr>
+              <a:t>ℰ</a:t>
+            </a:r>
+            <a:r>
+              <a:rPr lang="en-US" dirty="0" err="1"/>
+              <a:t>⟦e⟧s</a:t>
+            </a:r>
+            <a:r>
+              <a:rPr lang="en-US" dirty="0"/>
+              <a:t> </a:t>
+            </a:r>
+            <a:r>
+              <a:rPr lang="en-US" b="1" dirty="0"/>
+              <a:t>else</a:t>
+            </a:r>
+            <a:r>
+              <a:rPr lang="en-US" dirty="0"/>
+              <a:t> s </a:t>
+            </a:r>
+            <a:r>
+              <a:rPr lang="en-US" i="1" dirty="0" err="1"/>
+              <a:t>varname</a:t>
+            </a:r>
+            <a:r>
+              <a:rPr lang="en-US" dirty="0"/>
+              <a:t>)</a:t>
             </a:r>
           </a:p>
           <a:p>

</xml_diff>